<commit_message>
Р7: 'where the agent lives' sheet per lesson 9 (payback threshold, per-step perimeter, pilot scope with dates, security questions); deck in Arial
Co-Authored-By: Claude Opus 5.5 <noreply@anthropic.com>
</commit_message>
<xml_diff>
--- a/course/deck/agent_deck.pptx
+++ b/course/deck/agent_deck.pptx
@@ -1481,9 +1481,9 @@
                 <a:solidFill>
                   <a:srgbClr val="FFFFFF"/>
                 </a:solidFill>
-                <a:latin typeface="Golos Text DemiBold" pitchFamily="34" charset="0"/>
-                <a:ea typeface="Golos Text DemiBold" pitchFamily="34" charset="-122"/>
-                <a:cs typeface="Golos Text DemiBold" pitchFamily="34" charset="-120"/>
+                <a:latin typeface="Arial" pitchFamily="34" charset="0"/>
+                <a:ea typeface="Arial" pitchFamily="34" charset="-122"/>
+                <a:cs typeface="Arial" pitchFamily="34" charset="-120"/>
               </a:rPr>
               <a:t>АГЕНТ КОНТРОЛЯ</a:t>
             </a:r>
@@ -1498,9 +1498,9 @@
                 <a:solidFill>
                   <a:srgbClr val="FFFFFF"/>
                 </a:solidFill>
-                <a:latin typeface="Golos Text DemiBold" pitchFamily="34" charset="0"/>
-                <a:ea typeface="Golos Text DemiBold" pitchFamily="34" charset="-122"/>
-                <a:cs typeface="Golos Text DemiBold" pitchFamily="34" charset="-120"/>
+                <a:latin typeface="Arial" pitchFamily="34" charset="0"/>
+                <a:ea typeface="Arial" pitchFamily="34" charset="-122"/>
+                <a:cs typeface="Arial" pitchFamily="34" charset="-120"/>
               </a:rPr>
               <a:t>ДОБЫЧИ КУСТА</a:t>
             </a:r>
@@ -1537,9 +1537,9 @@
                 <a:solidFill>
                   <a:srgbClr val="FFFFFF"/>
                 </a:solidFill>
-                <a:latin typeface="Golos Text" pitchFamily="34" charset="0"/>
-                <a:ea typeface="Golos Text" pitchFamily="34" charset="-122"/>
-                <a:cs typeface="Golos Text" pitchFamily="34" charset="-120"/>
+                <a:latin typeface="Arial" pitchFamily="34" charset="0"/>
+                <a:ea typeface="Arial" pitchFamily="34" charset="-122"/>
+                <a:cs typeface="Arial" pitchFamily="34" charset="-120"/>
               </a:rPr>
               <a:t>Недобор нефти найден и рассчитан за 1.5 часа вместо 10</a:t>
             </a:r>
@@ -1605,9 +1605,9 @@
                 <a:solidFill>
                   <a:srgbClr val="A7A6A6"/>
                 </a:solidFill>
-                <a:latin typeface="Golos Text" pitchFamily="34" charset="0"/>
-                <a:ea typeface="Golos Text" pitchFamily="34" charset="-122"/>
-                <a:cs typeface="Golos Text" pitchFamily="34" charset="-120"/>
+                <a:latin typeface="Arial" pitchFamily="34" charset="0"/>
+                <a:ea typeface="Arial" pitchFamily="34" charset="-122"/>
+                <a:cs typeface="Arial" pitchFamily="34" charset="-120"/>
               </a:rPr>
               <a:t>Паспорт агента · Блок 3 «Agentic Workflow» · октябрь 2026</a:t>
             </a:r>
@@ -1720,9 +1720,9 @@
                 <a:solidFill>
                   <a:srgbClr val="A7A6A6"/>
                 </a:solidFill>
-                <a:latin typeface="Golos Text" pitchFamily="34" charset="0"/>
-                <a:ea typeface="Golos Text" pitchFamily="34" charset="-122"/>
-                <a:cs typeface="Golos Text" pitchFamily="34" charset="-120"/>
+                <a:latin typeface="Arial" pitchFamily="34" charset="0"/>
+                <a:ea typeface="Arial" pitchFamily="34" charset="-122"/>
+                <a:cs typeface="Arial" pitchFamily="34" charset="-120"/>
               </a:rPr>
               <a:t>2</a:t>
             </a:r>
@@ -1759,9 +1759,9 @@
                 <a:solidFill>
                   <a:srgbClr val="41008C"/>
                 </a:solidFill>
-                <a:latin typeface="Golos Text DemiBold" pitchFamily="34" charset="0"/>
-                <a:ea typeface="Golos Text DemiBold" pitchFamily="34" charset="-122"/>
-                <a:cs typeface="Golos Text DemiBold" pitchFamily="34" charset="-120"/>
+                <a:latin typeface="Arial" pitchFamily="34" charset="0"/>
+                <a:ea typeface="Arial" pitchFamily="34" charset="-122"/>
+                <a:cs typeface="Arial" pitchFamily="34" charset="-120"/>
               </a:rPr>
               <a:t>NS Digital</a:t>
             </a:r>
@@ -1773,9 +1773,9 @@
                 <a:solidFill>
                   <a:srgbClr val="19003C"/>
                 </a:solidFill>
-                <a:latin typeface="Golos Text DemiBold" pitchFamily="34" charset="0"/>
-                <a:ea typeface="Golos Text DemiBold" pitchFamily="34" charset="-122"/>
-                <a:cs typeface="Golos Text DemiBold" pitchFamily="34" charset="-120"/>
+                <a:latin typeface="Arial" pitchFamily="34" charset="0"/>
+                <a:ea typeface="Arial" pitchFamily="34" charset="-122"/>
+                <a:cs typeface="Arial" pitchFamily="34" charset="-120"/>
               </a:rPr>
               <a:t> / Проблема</a:t>
             </a:r>
@@ -1835,9 +1835,9 @@
                 <a:solidFill>
                   <a:srgbClr val="19003C"/>
                 </a:solidFill>
-                <a:latin typeface="Golos Text DemiBold" pitchFamily="34" charset="0"/>
-                <a:ea typeface="Golos Text DemiBold" pitchFamily="34" charset="-122"/>
-                <a:cs typeface="Golos Text DemiBold" pitchFamily="34" charset="-120"/>
+                <a:latin typeface="Arial" pitchFamily="34" charset="0"/>
+                <a:ea typeface="Arial" pitchFamily="34" charset="-122"/>
+                <a:cs typeface="Arial" pitchFamily="34" charset="-120"/>
               </a:rPr>
               <a:t>НЕДОБОР ЗАМЕЧАЮТ И СЧИТАЮТ ВРУЧНУЮ — КОМПЕНСАЦИЯ НАЧИНАЕТСЯ ЧЕРЕЗ 18 ЧАСОВ</a:t>
             </a:r>
@@ -1894,9 +1894,9 @@
                 <a:solidFill>
                   <a:srgbClr val="41008C"/>
                 </a:solidFill>
-                <a:latin typeface="Golos Text DemiBold" pitchFamily="34" charset="0"/>
-                <a:ea typeface="Golos Text DemiBold" pitchFamily="34" charset="-122"/>
-                <a:cs typeface="Golos Text DemiBold" pitchFamily="34" charset="-120"/>
+                <a:latin typeface="Arial" pitchFamily="34" charset="0"/>
+                <a:ea typeface="Arial" pitchFamily="34" charset="-122"/>
+                <a:cs typeface="Arial" pitchFamily="34" charset="-120"/>
               </a:rPr>
               <a:t>18 ч</a:t>
             </a:r>
@@ -1933,9 +1933,9 @@
                 <a:solidFill>
                   <a:srgbClr val="19003C"/>
                 </a:solidFill>
-                <a:latin typeface="Golos Text" pitchFamily="34" charset="0"/>
-                <a:ea typeface="Golos Text" pitchFamily="34" charset="-122"/>
-                <a:cs typeface="Golos Text" pitchFamily="34" charset="-120"/>
+                <a:latin typeface="Arial" pitchFamily="34" charset="0"/>
+                <a:ea typeface="Arial" pitchFamily="34" charset="-122"/>
+                <a:cs typeface="Arial" pitchFamily="34" charset="-120"/>
               </a:rPr>
               <a:t>от обнаружения отклонения до действия на скважинах</a:t>
             </a:r>
@@ -1992,9 +1992,9 @@
                 <a:solidFill>
                   <a:srgbClr val="41008C"/>
                 </a:solidFill>
-                <a:latin typeface="Golos Text DemiBold" pitchFamily="34" charset="0"/>
-                <a:ea typeface="Golos Text DemiBold" pitchFamily="34" charset="-122"/>
-                <a:cs typeface="Golos Text DemiBold" pitchFamily="34" charset="-120"/>
+                <a:latin typeface="Arial" pitchFamily="34" charset="0"/>
+                <a:ea typeface="Arial" pitchFamily="34" charset="-122"/>
+                <a:cs typeface="Arial" pitchFamily="34" charset="-120"/>
               </a:rPr>
               <a:t>10 ч</a:t>
             </a:r>
@@ -2031,9 +2031,9 @@
                 <a:solidFill>
                   <a:srgbClr val="19003C"/>
                 </a:solidFill>
-                <a:latin typeface="Golos Text" pitchFamily="34" charset="0"/>
-                <a:ea typeface="Golos Text" pitchFamily="34" charset="-122"/>
-                <a:cs typeface="Golos Text" pitchFamily="34" charset="-120"/>
+                <a:latin typeface="Arial" pitchFamily="34" charset="0"/>
+                <a:ea typeface="Arial" pitchFamily="34" charset="-122"/>
+                <a:cs typeface="Arial" pitchFamily="34" charset="-120"/>
               </a:rPr>
               <a:t>из них — обнаружение отклонения и ручной расчёт в PetEx</a:t>
             </a:r>
@@ -2090,9 +2090,9 @@
                 <a:solidFill>
                   <a:srgbClr val="00DD00"/>
                 </a:solidFill>
-                <a:latin typeface="Golos Text DemiBold" pitchFamily="34" charset="0"/>
-                <a:ea typeface="Golos Text DemiBold" pitchFamily="34" charset="-122"/>
-                <a:cs typeface="Golos Text DemiBold" pitchFamily="34" charset="-120"/>
+                <a:latin typeface="Arial" pitchFamily="34" charset="0"/>
+                <a:ea typeface="Arial" pitchFamily="34" charset="-122"/>
+                <a:cs typeface="Arial" pitchFamily="34" charset="-120"/>
               </a:rPr>
               <a:t>10.7 т</a:t>
             </a:r>
@@ -2129,9 +2129,9 @@
                 <a:solidFill>
                   <a:srgbClr val="19003C"/>
                 </a:solidFill>
-                <a:latin typeface="Golos Text" pitchFamily="34" charset="0"/>
-                <a:ea typeface="Golos Text" pitchFamily="34" charset="-122"/>
-                <a:cs typeface="Golos Text" pitchFamily="34" charset="-120"/>
+                <a:latin typeface="Arial" pitchFamily="34" charset="0"/>
+                <a:ea typeface="Arial" pitchFamily="34" charset="-122"/>
+                <a:cs typeface="Arial" pitchFamily="34" charset="-120"/>
               </a:rPr>
               <a:t>нескомпенсированной нефти на один инцидент — 213 тыс. руб</a:t>
             </a:r>
@@ -2188,9 +2188,9 @@
                 <a:solidFill>
                   <a:srgbClr val="41008C"/>
                 </a:solidFill>
-                <a:latin typeface="Golos Text DemiBold" pitchFamily="34" charset="0"/>
-                <a:ea typeface="Golos Text DemiBold" pitchFamily="34" charset="-122"/>
-                <a:cs typeface="Golos Text DemiBold" pitchFamily="34" charset="-120"/>
+                <a:latin typeface="Arial" pitchFamily="34" charset="0"/>
+                <a:ea typeface="Arial" pitchFamily="34" charset="-122"/>
+                <a:cs typeface="Arial" pitchFamily="34" charset="-120"/>
               </a:rPr>
               <a:t>552 мин</a:t>
             </a:r>
@@ -2227,9 +2227,9 @@
                 <a:solidFill>
                   <a:srgbClr val="19003C"/>
                 </a:solidFill>
-                <a:latin typeface="Golos Text" pitchFamily="34" charset="0"/>
-                <a:ea typeface="Golos Text" pitchFamily="34" charset="-122"/>
-                <a:cs typeface="Golos Text" pitchFamily="34" charset="-120"/>
+                <a:latin typeface="Arial" pitchFamily="34" charset="0"/>
+                <a:ea typeface="Arial" pitchFamily="34" charset="-122"/>
+                <a:cs typeface="Arial" pitchFamily="34" charset="-120"/>
               </a:rPr>
               <a:t>в неделю инженера-моделиста на проверке гипотез и расчёте режима</a:t>
             </a:r>
@@ -2288,9 +2288,9 @@
                 <a:solidFill>
                   <a:srgbClr val="FFFFFF"/>
                 </a:solidFill>
-                <a:latin typeface="Golos Text DemiBold" pitchFamily="34" charset="0"/>
-                <a:ea typeface="Golos Text DemiBold" pitchFamily="34" charset="-122"/>
-                <a:cs typeface="Golos Text DemiBold" pitchFamily="34" charset="-120"/>
+                <a:latin typeface="Arial" pitchFamily="34" charset="0"/>
+                <a:ea typeface="Arial" pitchFamily="34" charset="-122"/>
+                <a:cs typeface="Arial" pitchFamily="34" charset="-120"/>
               </a:rPr>
               <a:t>Потеря нефти растёт каждый час, пока отклонение ждёт человека и ручного расчёта</a:t>
             </a:r>
@@ -2327,9 +2327,9 @@
                 <a:solidFill>
                   <a:srgbClr val="A7A6A6"/>
                 </a:solidFill>
-                <a:latin typeface="Golos Text" pitchFamily="34" charset="0"/>
-                <a:ea typeface="Golos Text" pitchFamily="34" charset="-122"/>
-                <a:cs typeface="Golos Text" pitchFamily="34" charset="-120"/>
+                <a:latin typeface="Arial" pitchFamily="34" charset="0"/>
+                <a:ea typeface="Arial" pitchFamily="34" charset="-122"/>
+                <a:cs typeface="Arial" pitchFamily="34" charset="-120"/>
               </a:rPr>
               <a:t>Источник: отчёт по диагностическому аудиту бизнес-процессов Заказчика (18 ч / 10 ч). Нефть — расчёт на учебном кейсе: потеря 14.2 т/сут × 18 ч / 24, 20 000 руб/т.</a:t>
             </a:r>
@@ -2442,9 +2442,9 @@
                 <a:solidFill>
                   <a:srgbClr val="A7A6A6"/>
                 </a:solidFill>
-                <a:latin typeface="Golos Text" pitchFamily="34" charset="0"/>
-                <a:ea typeface="Golos Text" pitchFamily="34" charset="-122"/>
-                <a:cs typeface="Golos Text" pitchFamily="34" charset="-120"/>
+                <a:latin typeface="Arial" pitchFamily="34" charset="0"/>
+                <a:ea typeface="Arial" pitchFamily="34" charset="-122"/>
+                <a:cs typeface="Arial" pitchFamily="34" charset="-120"/>
               </a:rPr>
               <a:t>3</a:t>
             </a:r>
@@ -2481,9 +2481,9 @@
                 <a:solidFill>
                   <a:srgbClr val="41008C"/>
                 </a:solidFill>
-                <a:latin typeface="Golos Text DemiBold" pitchFamily="34" charset="0"/>
-                <a:ea typeface="Golos Text DemiBold" pitchFamily="34" charset="-122"/>
-                <a:cs typeface="Golos Text DemiBold" pitchFamily="34" charset="-120"/>
+                <a:latin typeface="Arial" pitchFamily="34" charset="0"/>
+                <a:ea typeface="Arial" pitchFamily="34" charset="-122"/>
+                <a:cs typeface="Arial" pitchFamily="34" charset="-120"/>
               </a:rPr>
               <a:t>NS Digital</a:t>
             </a:r>
@@ -2495,9 +2495,9 @@
                 <a:solidFill>
                   <a:srgbClr val="19003C"/>
                 </a:solidFill>
-                <a:latin typeface="Golos Text DemiBold" pitchFamily="34" charset="0"/>
-                <a:ea typeface="Golos Text DemiBold" pitchFamily="34" charset="-122"/>
-                <a:cs typeface="Golos Text DemiBold" pitchFamily="34" charset="-120"/>
+                <a:latin typeface="Arial" pitchFamily="34" charset="0"/>
+                <a:ea typeface="Arial" pitchFamily="34" charset="-122"/>
+                <a:cs typeface="Arial" pitchFamily="34" charset="-120"/>
               </a:rPr>
               <a:t> / Как сейчас (As-Is)</a:t>
             </a:r>
@@ -2557,9 +2557,9 @@
                 <a:solidFill>
                   <a:srgbClr val="19003C"/>
                 </a:solidFill>
-                <a:latin typeface="Golos Text DemiBold" pitchFamily="34" charset="0"/>
-                <a:ea typeface="Golos Text DemiBold" pitchFamily="34" charset="-122"/>
-                <a:cs typeface="Golos Text DemiBold" pitchFamily="34" charset="-120"/>
+                <a:latin typeface="Arial" pitchFamily="34" charset="0"/>
+                <a:ea typeface="Arial" pitchFamily="34" charset="-122"/>
+                <a:cs typeface="Arial" pitchFamily="34" charset="-120"/>
               </a:rPr>
               <a:t>УЗКОЕ МЕСТО — РУЧНАЯ ПРОВЕРКА ГИПОТЕЗ И РАСЧЁТ РЕЖИМА: 46 % ВРЕМЕНИ</a:t>
             </a:r>
@@ -2611,16 +2611,16 @@
                           <a:solidFill>
                             <a:srgbClr val="19003C"/>
                           </a:solidFill>
-                          <a:latin typeface="Golos Text DemiBold" pitchFamily="34" charset="0"/>
-                          <a:ea typeface="Golos Text DemiBold" pitchFamily="34" charset="-122"/>
-                          <a:cs typeface="Golos Text DemiBold" pitchFamily="34" charset="-120"/>
+                          <a:latin typeface="Arial" pitchFamily="34" charset="0"/>
+                          <a:ea typeface="Arial" pitchFamily="34" charset="-122"/>
+                          <a:cs typeface="Arial" pitchFamily="34" charset="-120"/>
                         </a:rPr>
                         <a:t>№</a:t>
                       </a:r>
                       <a:endParaRPr lang="en-US" sz="1200" dirty="0">
-                        <a:latin typeface="Golos Text DemiBold" charset="0"/>
-                        <a:ea typeface="Golos Text DemiBold" charset="0"/>
-                        <a:cs typeface="Golos Text DemiBold" charset="0"/>
+                        <a:latin typeface="Arial" charset="0"/>
+                        <a:ea typeface="Arial" charset="0"/>
+                        <a:cs typeface="Arial" charset="0"/>
                       </a:endParaRPr>
                     </a:p>
                   </a:txBody>
@@ -2679,16 +2679,16 @@
                           <a:solidFill>
                             <a:srgbClr val="19003C"/>
                           </a:solidFill>
-                          <a:latin typeface="Golos Text DemiBold" pitchFamily="34" charset="0"/>
-                          <a:ea typeface="Golos Text DemiBold" pitchFamily="34" charset="-122"/>
-                          <a:cs typeface="Golos Text DemiBold" pitchFamily="34" charset="-120"/>
+                          <a:latin typeface="Arial" pitchFamily="34" charset="0"/>
+                          <a:ea typeface="Arial" pitchFamily="34" charset="-122"/>
+                          <a:cs typeface="Arial" pitchFamily="34" charset="-120"/>
                         </a:rPr>
                         <a:t>Шаг</a:t>
                       </a:r>
                       <a:endParaRPr lang="en-US" sz="1200" dirty="0">
-                        <a:latin typeface="Golos Text DemiBold" charset="0"/>
-                        <a:ea typeface="Golos Text DemiBold" charset="0"/>
-                        <a:cs typeface="Golos Text DemiBold" charset="0"/>
+                        <a:latin typeface="Arial" charset="0"/>
+                        <a:ea typeface="Arial" charset="0"/>
+                        <a:cs typeface="Arial" charset="0"/>
                       </a:endParaRPr>
                     </a:p>
                   </a:txBody>
@@ -2747,16 +2747,16 @@
                           <a:solidFill>
                             <a:srgbClr val="19003C"/>
                           </a:solidFill>
-                          <a:latin typeface="Golos Text DemiBold" pitchFamily="34" charset="0"/>
-                          <a:ea typeface="Golos Text DemiBold" pitchFamily="34" charset="-122"/>
-                          <a:cs typeface="Golos Text DemiBold" pitchFamily="34" charset="-120"/>
+                          <a:latin typeface="Arial" pitchFamily="34" charset="0"/>
+                          <a:ea typeface="Arial" pitchFamily="34" charset="-122"/>
+                          <a:cs typeface="Arial" pitchFamily="34" charset="-120"/>
                         </a:rPr>
                         <a:t>Кто</a:t>
                       </a:r>
                       <a:endParaRPr lang="en-US" sz="1200" dirty="0">
-                        <a:latin typeface="Golos Text DemiBold" charset="0"/>
-                        <a:ea typeface="Golos Text DemiBold" charset="0"/>
-                        <a:cs typeface="Golos Text DemiBold" charset="0"/>
+                        <a:latin typeface="Arial" charset="0"/>
+                        <a:ea typeface="Arial" charset="0"/>
+                        <a:cs typeface="Arial" charset="0"/>
                       </a:endParaRPr>
                     </a:p>
                   </a:txBody>
@@ -2815,16 +2815,16 @@
                           <a:solidFill>
                             <a:srgbClr val="19003C"/>
                           </a:solidFill>
-                          <a:latin typeface="Golos Text DemiBold" pitchFamily="34" charset="0"/>
-                          <a:ea typeface="Golos Text DemiBold" pitchFamily="34" charset="-122"/>
-                          <a:cs typeface="Golos Text DemiBold" pitchFamily="34" charset="-120"/>
+                          <a:latin typeface="Arial" pitchFamily="34" charset="0"/>
+                          <a:ea typeface="Arial" pitchFamily="34" charset="-122"/>
+                          <a:cs typeface="Arial" pitchFamily="34" charset="-120"/>
                         </a:rPr>
                         <a:t>Мин</a:t>
                       </a:r>
                       <a:endParaRPr lang="en-US" sz="1200" dirty="0">
-                        <a:latin typeface="Golos Text DemiBold" charset="0"/>
-                        <a:ea typeface="Golos Text DemiBold" charset="0"/>
-                        <a:cs typeface="Golos Text DemiBold" charset="0"/>
+                        <a:latin typeface="Arial" charset="0"/>
+                        <a:ea typeface="Arial" charset="0"/>
+                        <a:cs typeface="Arial" charset="0"/>
                       </a:endParaRPr>
                     </a:p>
                   </a:txBody>
@@ -2883,16 +2883,16 @@
                           <a:solidFill>
                             <a:srgbClr val="19003C"/>
                           </a:solidFill>
-                          <a:latin typeface="Golos Text DemiBold" pitchFamily="34" charset="0"/>
-                          <a:ea typeface="Golos Text DemiBold" pitchFamily="34" charset="-122"/>
-                          <a:cs typeface="Golos Text DemiBold" pitchFamily="34" charset="-120"/>
+                          <a:latin typeface="Arial" pitchFamily="34" charset="0"/>
+                          <a:ea typeface="Arial" pitchFamily="34" charset="-122"/>
+                          <a:cs typeface="Arial" pitchFamily="34" charset="-120"/>
                         </a:rPr>
                         <a:t>Раз / нед</a:t>
                       </a:r>
                       <a:endParaRPr lang="en-US" sz="1200" dirty="0">
-                        <a:latin typeface="Golos Text DemiBold" charset="0"/>
-                        <a:ea typeface="Golos Text DemiBold" charset="0"/>
-                        <a:cs typeface="Golos Text DemiBold" charset="0"/>
+                        <a:latin typeface="Arial" charset="0"/>
+                        <a:ea typeface="Arial" charset="0"/>
+                        <a:cs typeface="Arial" charset="0"/>
                       </a:endParaRPr>
                     </a:p>
                   </a:txBody>
@@ -2951,16 +2951,16 @@
                           <a:solidFill>
                             <a:srgbClr val="19003C"/>
                           </a:solidFill>
-                          <a:latin typeface="Golos Text DemiBold" pitchFamily="34" charset="0"/>
-                          <a:ea typeface="Golos Text DemiBold" pitchFamily="34" charset="-122"/>
-                          <a:cs typeface="Golos Text DemiBold" pitchFamily="34" charset="-120"/>
+                          <a:latin typeface="Arial" pitchFamily="34" charset="0"/>
+                          <a:ea typeface="Arial" pitchFamily="34" charset="-122"/>
+                          <a:cs typeface="Arial" pitchFamily="34" charset="-120"/>
                         </a:rPr>
                         <a:t>Потеря, мин / нед</a:t>
                       </a:r>
                       <a:endParaRPr lang="en-US" sz="1200" dirty="0">
-                        <a:latin typeface="Golos Text DemiBold" charset="0"/>
-                        <a:ea typeface="Golos Text DemiBold" charset="0"/>
-                        <a:cs typeface="Golos Text DemiBold" charset="0"/>
+                        <a:latin typeface="Arial" charset="0"/>
+                        <a:ea typeface="Arial" charset="0"/>
+                        <a:cs typeface="Arial" charset="0"/>
                       </a:endParaRPr>
                     </a:p>
                   </a:txBody>
@@ -3021,16 +3021,16 @@
                           <a:solidFill>
                             <a:srgbClr val="19003C"/>
                           </a:solidFill>
-                          <a:latin typeface="Golos Text" pitchFamily="34" charset="0"/>
-                          <a:ea typeface="Golos Text" pitchFamily="34" charset="-122"/>
-                          <a:cs typeface="Golos Text" pitchFamily="34" charset="-120"/>
+                          <a:latin typeface="Arial" pitchFamily="34" charset="0"/>
+                          <a:ea typeface="Arial" pitchFamily="34" charset="-122"/>
+                          <a:cs typeface="Arial" pitchFamily="34" charset="-120"/>
                         </a:rPr>
                         <a:t>0</a:t>
                       </a:r>
                       <a:endParaRPr lang="en-US" sz="1200" dirty="0">
-                        <a:latin typeface="Golos Text" charset="0"/>
-                        <a:ea typeface="Golos Text" charset="0"/>
-                        <a:cs typeface="Golos Text" charset="0"/>
+                        <a:latin typeface="Arial" charset="0"/>
+                        <a:ea typeface="Arial" charset="0"/>
+                        <a:cs typeface="Arial" charset="0"/>
                       </a:endParaRPr>
                     </a:p>
                   </a:txBody>
@@ -3086,16 +3086,16 @@
                           <a:solidFill>
                             <a:srgbClr val="19003C"/>
                           </a:solidFill>
-                          <a:latin typeface="Golos Text" pitchFamily="34" charset="0"/>
-                          <a:ea typeface="Golos Text" pitchFamily="34" charset="-122"/>
-                          <a:cs typeface="Golos Text" pitchFamily="34" charset="-120"/>
+                          <a:latin typeface="Arial" pitchFamily="34" charset="0"/>
+                          <a:ea typeface="Arial" pitchFamily="34" charset="-122"/>
+                          <a:cs typeface="Arial" pitchFamily="34" charset="-120"/>
                         </a:rPr>
                         <a:t>Двухчасовка с добычей по сепаратору — отклонение видно только при просмотре</a:t>
                       </a:r>
                       <a:endParaRPr lang="en-US" sz="1200" dirty="0">
-                        <a:latin typeface="Golos Text" charset="0"/>
-                        <a:ea typeface="Golos Text" charset="0"/>
-                        <a:cs typeface="Golos Text" charset="0"/>
+                        <a:latin typeface="Arial" charset="0"/>
+                        <a:ea typeface="Arial" charset="0"/>
+                        <a:cs typeface="Arial" charset="0"/>
                       </a:endParaRPr>
                     </a:p>
                   </a:txBody>
@@ -3151,16 +3151,16 @@
                           <a:solidFill>
                             <a:srgbClr val="19003C"/>
                           </a:solidFill>
-                          <a:latin typeface="Golos Text" pitchFamily="34" charset="0"/>
-                          <a:ea typeface="Golos Text" pitchFamily="34" charset="-122"/>
-                          <a:cs typeface="Golos Text" pitchFamily="34" charset="-120"/>
+                          <a:latin typeface="Arial" pitchFamily="34" charset="0"/>
+                          <a:ea typeface="Arial" pitchFamily="34" charset="-122"/>
+                          <a:cs typeface="Arial" pitchFamily="34" charset="-120"/>
                         </a:rPr>
                         <a:t>регламент</a:t>
                       </a:r>
                       <a:endParaRPr lang="en-US" sz="1200" dirty="0">
-                        <a:latin typeface="Golos Text" charset="0"/>
-                        <a:ea typeface="Golos Text" charset="0"/>
-                        <a:cs typeface="Golos Text" charset="0"/>
+                        <a:latin typeface="Arial" charset="0"/>
+                        <a:ea typeface="Arial" charset="0"/>
+                        <a:cs typeface="Arial" charset="0"/>
                       </a:endParaRPr>
                     </a:p>
                   </a:txBody>
@@ -3216,16 +3216,16 @@
                           <a:solidFill>
                             <a:srgbClr val="19003C"/>
                           </a:solidFill>
-                          <a:latin typeface="Golos Text" pitchFamily="34" charset="0"/>
-                          <a:ea typeface="Golos Text" pitchFamily="34" charset="-122"/>
-                          <a:cs typeface="Golos Text" pitchFamily="34" charset="-120"/>
+                          <a:latin typeface="Arial" pitchFamily="34" charset="0"/>
+                          <a:ea typeface="Arial" pitchFamily="34" charset="-122"/>
+                          <a:cs typeface="Arial" pitchFamily="34" charset="-120"/>
                         </a:rPr>
                         <a:t>—</a:t>
                       </a:r>
                       <a:endParaRPr lang="en-US" sz="1200" dirty="0">
-                        <a:latin typeface="Golos Text" charset="0"/>
-                        <a:ea typeface="Golos Text" charset="0"/>
-                        <a:cs typeface="Golos Text" charset="0"/>
+                        <a:latin typeface="Arial" charset="0"/>
+                        <a:ea typeface="Arial" charset="0"/>
+                        <a:cs typeface="Arial" charset="0"/>
                       </a:endParaRPr>
                     </a:p>
                   </a:txBody>
@@ -3281,16 +3281,16 @@
                           <a:solidFill>
                             <a:srgbClr val="19003C"/>
                           </a:solidFill>
-                          <a:latin typeface="Golos Text" pitchFamily="34" charset="0"/>
-                          <a:ea typeface="Golos Text" pitchFamily="34" charset="-122"/>
-                          <a:cs typeface="Golos Text" pitchFamily="34" charset="-120"/>
+                          <a:latin typeface="Arial" pitchFamily="34" charset="0"/>
+                          <a:ea typeface="Arial" pitchFamily="34" charset="-122"/>
+                          <a:cs typeface="Arial" pitchFamily="34" charset="-120"/>
                         </a:rPr>
                         <a:t>—</a:t>
                       </a:r>
                       <a:endParaRPr lang="en-US" sz="1200" dirty="0">
-                        <a:latin typeface="Golos Text" charset="0"/>
-                        <a:ea typeface="Golos Text" charset="0"/>
-                        <a:cs typeface="Golos Text" charset="0"/>
+                        <a:latin typeface="Arial" charset="0"/>
+                        <a:ea typeface="Arial" charset="0"/>
+                        <a:cs typeface="Arial" charset="0"/>
                       </a:endParaRPr>
                     </a:p>
                   </a:txBody>
@@ -3346,16 +3346,16 @@
                           <a:solidFill>
                             <a:srgbClr val="19003C"/>
                           </a:solidFill>
-                          <a:latin typeface="Golos Text" pitchFamily="34" charset="0"/>
-                          <a:ea typeface="Golos Text" pitchFamily="34" charset="-122"/>
-                          <a:cs typeface="Golos Text" pitchFamily="34" charset="-120"/>
+                          <a:latin typeface="Arial" pitchFamily="34" charset="0"/>
+                          <a:ea typeface="Arial" pitchFamily="34" charset="-122"/>
+                          <a:cs typeface="Arial" pitchFamily="34" charset="-120"/>
                         </a:rPr>
                         <a:t>—</a:t>
                       </a:r>
                       <a:endParaRPr lang="en-US" sz="1200" dirty="0">
-                        <a:latin typeface="Golos Text" charset="0"/>
-                        <a:ea typeface="Golos Text" charset="0"/>
-                        <a:cs typeface="Golos Text" charset="0"/>
+                        <a:latin typeface="Arial" charset="0"/>
+                        <a:ea typeface="Arial" charset="0"/>
+                        <a:cs typeface="Arial" charset="0"/>
                       </a:endParaRPr>
                     </a:p>
                   </a:txBody>
@@ -3413,16 +3413,16 @@
                           <a:solidFill>
                             <a:srgbClr val="19003C"/>
                           </a:solidFill>
-                          <a:latin typeface="Golos Text" pitchFamily="34" charset="0"/>
-                          <a:ea typeface="Golos Text" pitchFamily="34" charset="-122"/>
-                          <a:cs typeface="Golos Text" pitchFamily="34" charset="-120"/>
+                          <a:latin typeface="Arial" pitchFamily="34" charset="0"/>
+                          <a:ea typeface="Arial" pitchFamily="34" charset="-122"/>
+                          <a:cs typeface="Arial" pitchFamily="34" charset="-120"/>
                         </a:rPr>
                         <a:t>1</a:t>
                       </a:r>
                       <a:endParaRPr lang="en-US" sz="1200" dirty="0">
-                        <a:latin typeface="Golos Text" charset="0"/>
-                        <a:ea typeface="Golos Text" charset="0"/>
-                        <a:cs typeface="Golos Text" charset="0"/>
+                        <a:latin typeface="Arial" charset="0"/>
+                        <a:ea typeface="Arial" charset="0"/>
+                        <a:cs typeface="Arial" charset="0"/>
                       </a:endParaRPr>
                     </a:p>
                   </a:txBody>
@@ -3478,16 +3478,16 @@
                           <a:solidFill>
                             <a:srgbClr val="19003C"/>
                           </a:solidFill>
-                          <a:latin typeface="Golos Text" pitchFamily="34" charset="0"/>
-                          <a:ea typeface="Golos Text" pitchFamily="34" charset="-122"/>
-                          <a:cs typeface="Golos Text" pitchFamily="34" charset="-120"/>
+                          <a:latin typeface="Arial" pitchFamily="34" charset="0"/>
+                          <a:ea typeface="Arial" pitchFamily="34" charset="-122"/>
+                          <a:cs typeface="Arial" pitchFamily="34" charset="-120"/>
                         </a:rPr>
                         <a:t>Выгрузить телеметрию и замеры</a:t>
                       </a:r>
                       <a:endParaRPr lang="en-US" sz="1200" dirty="0">
-                        <a:latin typeface="Golos Text" charset="0"/>
-                        <a:ea typeface="Golos Text" charset="0"/>
-                        <a:cs typeface="Golos Text" charset="0"/>
+                        <a:latin typeface="Arial" charset="0"/>
+                        <a:ea typeface="Arial" charset="0"/>
+                        <a:cs typeface="Arial" charset="0"/>
                       </a:endParaRPr>
                     </a:p>
                   </a:txBody>
@@ -3543,16 +3543,16 @@
                           <a:solidFill>
                             <a:srgbClr val="19003C"/>
                           </a:solidFill>
-                          <a:latin typeface="Golos Text" pitchFamily="34" charset="0"/>
-                          <a:ea typeface="Golos Text" pitchFamily="34" charset="-122"/>
-                          <a:cs typeface="Golos Text" pitchFamily="34" charset="-120"/>
+                          <a:latin typeface="Arial" pitchFamily="34" charset="0"/>
+                          <a:ea typeface="Arial" pitchFamily="34" charset="-122"/>
+                          <a:cs typeface="Arial" pitchFamily="34" charset="-120"/>
                         </a:rPr>
                         <a:t>инженер, скрипт</a:t>
                       </a:r>
                       <a:endParaRPr lang="en-US" sz="1200" dirty="0">
-                        <a:latin typeface="Golos Text" charset="0"/>
-                        <a:ea typeface="Golos Text" charset="0"/>
-                        <a:cs typeface="Golos Text" charset="0"/>
+                        <a:latin typeface="Arial" charset="0"/>
+                        <a:ea typeface="Arial" charset="0"/>
+                        <a:cs typeface="Arial" charset="0"/>
                       </a:endParaRPr>
                     </a:p>
                   </a:txBody>
@@ -3608,16 +3608,16 @@
                           <a:solidFill>
                             <a:srgbClr val="19003C"/>
                           </a:solidFill>
-                          <a:latin typeface="Golos Text" pitchFamily="34" charset="0"/>
-                          <a:ea typeface="Golos Text" pitchFamily="34" charset="-122"/>
-                          <a:cs typeface="Golos Text" pitchFamily="34" charset="-120"/>
+                          <a:latin typeface="Arial" pitchFamily="34" charset="0"/>
+                          <a:ea typeface="Arial" pitchFamily="34" charset="-122"/>
+                          <a:cs typeface="Arial" pitchFamily="34" charset="-120"/>
                         </a:rPr>
                         <a:t>20</a:t>
                       </a:r>
                       <a:endParaRPr lang="en-US" sz="1200" dirty="0">
-                        <a:latin typeface="Golos Text" charset="0"/>
-                        <a:ea typeface="Golos Text" charset="0"/>
-                        <a:cs typeface="Golos Text" charset="0"/>
+                        <a:latin typeface="Arial" charset="0"/>
+                        <a:ea typeface="Arial" charset="0"/>
+                        <a:cs typeface="Arial" charset="0"/>
                       </a:endParaRPr>
                     </a:p>
                   </a:txBody>
@@ -3673,16 +3673,16 @@
                           <a:solidFill>
                             <a:srgbClr val="19003C"/>
                           </a:solidFill>
-                          <a:latin typeface="Golos Text" pitchFamily="34" charset="0"/>
-                          <a:ea typeface="Golos Text" pitchFamily="34" charset="-122"/>
-                          <a:cs typeface="Golos Text" pitchFamily="34" charset="-120"/>
+                          <a:latin typeface="Arial" pitchFamily="34" charset="0"/>
+                          <a:ea typeface="Arial" pitchFamily="34" charset="-122"/>
+                          <a:cs typeface="Arial" pitchFamily="34" charset="-120"/>
                         </a:rPr>
                         <a:t>5</a:t>
                       </a:r>
                       <a:endParaRPr lang="en-US" sz="1200" dirty="0">
-                        <a:latin typeface="Golos Text" charset="0"/>
-                        <a:ea typeface="Golos Text" charset="0"/>
-                        <a:cs typeface="Golos Text" charset="0"/>
+                        <a:latin typeface="Arial" charset="0"/>
+                        <a:ea typeface="Arial" charset="0"/>
+                        <a:cs typeface="Arial" charset="0"/>
                       </a:endParaRPr>
                     </a:p>
                   </a:txBody>
@@ -3738,16 +3738,16 @@
                           <a:solidFill>
                             <a:srgbClr val="19003C"/>
                           </a:solidFill>
-                          <a:latin typeface="Golos Text" pitchFamily="34" charset="0"/>
-                          <a:ea typeface="Golos Text" pitchFamily="34" charset="-122"/>
-                          <a:cs typeface="Golos Text" pitchFamily="34" charset="-120"/>
+                          <a:latin typeface="Arial" pitchFamily="34" charset="0"/>
+                          <a:ea typeface="Arial" pitchFamily="34" charset="-122"/>
+                          <a:cs typeface="Arial" pitchFamily="34" charset="-120"/>
                         </a:rPr>
                         <a:t>100</a:t>
                       </a:r>
                       <a:endParaRPr lang="en-US" sz="1200" dirty="0">
-                        <a:latin typeface="Golos Text" charset="0"/>
-                        <a:ea typeface="Golos Text" charset="0"/>
-                        <a:cs typeface="Golos Text" charset="0"/>
+                        <a:latin typeface="Arial" charset="0"/>
+                        <a:ea typeface="Arial" charset="0"/>
+                        <a:cs typeface="Arial" charset="0"/>
                       </a:endParaRPr>
                     </a:p>
                   </a:txBody>
@@ -3805,16 +3805,16 @@
                           <a:solidFill>
                             <a:srgbClr val="19003C"/>
                           </a:solidFill>
-                          <a:latin typeface="Golos Text" pitchFamily="34" charset="0"/>
-                          <a:ea typeface="Golos Text" pitchFamily="34" charset="-122"/>
-                          <a:cs typeface="Golos Text" pitchFamily="34" charset="-120"/>
+                          <a:latin typeface="Arial" pitchFamily="34" charset="0"/>
+                          <a:ea typeface="Arial" pitchFamily="34" charset="-122"/>
+                          <a:cs typeface="Arial" pitchFamily="34" charset="-120"/>
                         </a:rPr>
                         <a:t>2</a:t>
                       </a:r>
                       <a:endParaRPr lang="en-US" sz="1200" dirty="0">
-                        <a:latin typeface="Golos Text" charset="0"/>
-                        <a:ea typeface="Golos Text" charset="0"/>
-                        <a:cs typeface="Golos Text" charset="0"/>
+                        <a:latin typeface="Arial" charset="0"/>
+                        <a:ea typeface="Arial" charset="0"/>
+                        <a:cs typeface="Arial" charset="0"/>
                       </a:endParaRPr>
                     </a:p>
                   </a:txBody>
@@ -3870,16 +3870,16 @@
                           <a:solidFill>
                             <a:srgbClr val="19003C"/>
                           </a:solidFill>
-                          <a:latin typeface="Golos Text" pitchFamily="34" charset="0"/>
-                          <a:ea typeface="Golos Text" pitchFamily="34" charset="-122"/>
-                          <a:cs typeface="Golos Text" pitchFamily="34" charset="-120"/>
+                          <a:latin typeface="Arial" pitchFamily="34" charset="0"/>
+                          <a:ea typeface="Arial" pitchFamily="34" charset="-122"/>
+                          <a:cs typeface="Arial" pitchFamily="34" charset="-120"/>
                         </a:rPr>
                         <a:t>Отбраковать замеры</a:t>
                       </a:r>
                       <a:endParaRPr lang="en-US" sz="1200" dirty="0">
-                        <a:latin typeface="Golos Text" charset="0"/>
-                        <a:ea typeface="Golos Text" charset="0"/>
-                        <a:cs typeface="Golos Text" charset="0"/>
+                        <a:latin typeface="Arial" charset="0"/>
+                        <a:ea typeface="Arial" charset="0"/>
+                        <a:cs typeface="Arial" charset="0"/>
                       </a:endParaRPr>
                     </a:p>
                   </a:txBody>
@@ -3935,16 +3935,16 @@
                           <a:solidFill>
                             <a:srgbClr val="19003C"/>
                           </a:solidFill>
-                          <a:latin typeface="Golos Text" pitchFamily="34" charset="0"/>
-                          <a:ea typeface="Golos Text" pitchFamily="34" charset="-122"/>
-                          <a:cs typeface="Golos Text" pitchFamily="34" charset="-120"/>
+                          <a:latin typeface="Arial" pitchFamily="34" charset="0"/>
+                          <a:ea typeface="Arial" pitchFamily="34" charset="-122"/>
+                          <a:cs typeface="Arial" pitchFamily="34" charset="-120"/>
                         </a:rPr>
                         <a:t>скрипт + инженер</a:t>
                       </a:r>
                       <a:endParaRPr lang="en-US" sz="1200" dirty="0">
-                        <a:latin typeface="Golos Text" charset="0"/>
-                        <a:ea typeface="Golos Text" charset="0"/>
-                        <a:cs typeface="Golos Text" charset="0"/>
+                        <a:latin typeface="Arial" charset="0"/>
+                        <a:ea typeface="Arial" charset="0"/>
+                        <a:cs typeface="Arial" charset="0"/>
                       </a:endParaRPr>
                     </a:p>
                   </a:txBody>
@@ -4000,16 +4000,16 @@
                           <a:solidFill>
                             <a:srgbClr val="19003C"/>
                           </a:solidFill>
-                          <a:latin typeface="Golos Text" pitchFamily="34" charset="0"/>
-                          <a:ea typeface="Golos Text" pitchFamily="34" charset="-122"/>
-                          <a:cs typeface="Golos Text" pitchFamily="34" charset="-120"/>
+                          <a:latin typeface="Arial" pitchFamily="34" charset="0"/>
+                          <a:ea typeface="Arial" pitchFamily="34" charset="-122"/>
+                          <a:cs typeface="Arial" pitchFamily="34" charset="-120"/>
                         </a:rPr>
                         <a:t>60</a:t>
                       </a:r>
                       <a:endParaRPr lang="en-US" sz="1200" dirty="0">
-                        <a:latin typeface="Golos Text" charset="0"/>
-                        <a:ea typeface="Golos Text" charset="0"/>
-                        <a:cs typeface="Golos Text" charset="0"/>
+                        <a:latin typeface="Arial" charset="0"/>
+                        <a:ea typeface="Arial" charset="0"/>
+                        <a:cs typeface="Arial" charset="0"/>
                       </a:endParaRPr>
                     </a:p>
                   </a:txBody>
@@ -4065,16 +4065,16 @@
                           <a:solidFill>
                             <a:srgbClr val="19003C"/>
                           </a:solidFill>
-                          <a:latin typeface="Golos Text" pitchFamily="34" charset="0"/>
-                          <a:ea typeface="Golos Text" pitchFamily="34" charset="-122"/>
-                          <a:cs typeface="Golos Text" pitchFamily="34" charset="-120"/>
+                          <a:latin typeface="Arial" pitchFamily="34" charset="0"/>
+                          <a:ea typeface="Arial" pitchFamily="34" charset="-122"/>
+                          <a:cs typeface="Arial" pitchFamily="34" charset="-120"/>
                         </a:rPr>
                         <a:t>5</a:t>
                       </a:r>
                       <a:endParaRPr lang="en-US" sz="1200" dirty="0">
-                        <a:latin typeface="Golos Text" charset="0"/>
-                        <a:ea typeface="Golos Text" charset="0"/>
-                        <a:cs typeface="Golos Text" charset="0"/>
+                        <a:latin typeface="Arial" charset="0"/>
+                        <a:ea typeface="Arial" charset="0"/>
+                        <a:cs typeface="Arial" charset="0"/>
                       </a:endParaRPr>
                     </a:p>
                   </a:txBody>
@@ -4130,16 +4130,16 @@
                           <a:solidFill>
                             <a:srgbClr val="19003C"/>
                           </a:solidFill>
-                          <a:latin typeface="Golos Text" pitchFamily="34" charset="0"/>
-                          <a:ea typeface="Golos Text" pitchFamily="34" charset="-122"/>
-                          <a:cs typeface="Golos Text" pitchFamily="34" charset="-120"/>
+                          <a:latin typeface="Arial" pitchFamily="34" charset="0"/>
+                          <a:ea typeface="Arial" pitchFamily="34" charset="-122"/>
+                          <a:cs typeface="Arial" pitchFamily="34" charset="-120"/>
                         </a:rPr>
                         <a:t>300</a:t>
                       </a:r>
                       <a:endParaRPr lang="en-US" sz="1200" dirty="0">
-                        <a:latin typeface="Golos Text" charset="0"/>
-                        <a:ea typeface="Golos Text" charset="0"/>
-                        <a:cs typeface="Golos Text" charset="0"/>
+                        <a:latin typeface="Arial" charset="0"/>
+                        <a:ea typeface="Arial" charset="0"/>
+                        <a:cs typeface="Arial" charset="0"/>
                       </a:endParaRPr>
                     </a:p>
                   </a:txBody>
@@ -4197,16 +4197,16 @@
                           <a:solidFill>
                             <a:srgbClr val="19003C"/>
                           </a:solidFill>
-                          <a:latin typeface="Golos Text" pitchFamily="34" charset="0"/>
-                          <a:ea typeface="Golos Text" pitchFamily="34" charset="-122"/>
-                          <a:cs typeface="Golos Text" pitchFamily="34" charset="-120"/>
+                          <a:latin typeface="Arial" pitchFamily="34" charset="0"/>
+                          <a:ea typeface="Arial" pitchFamily="34" charset="-122"/>
+                          <a:cs typeface="Arial" pitchFamily="34" charset="-120"/>
                         </a:rPr>
                         <a:t>3</a:t>
                       </a:r>
                       <a:endParaRPr lang="en-US" sz="1200" dirty="0">
-                        <a:latin typeface="Golos Text" charset="0"/>
-                        <a:ea typeface="Golos Text" charset="0"/>
-                        <a:cs typeface="Golos Text" charset="0"/>
+                        <a:latin typeface="Arial" charset="0"/>
+                        <a:ea typeface="Arial" charset="0"/>
+                        <a:cs typeface="Arial" charset="0"/>
                       </a:endParaRPr>
                     </a:p>
                   </a:txBody>
@@ -4262,16 +4262,16 @@
                           <a:solidFill>
                             <a:srgbClr val="19003C"/>
                           </a:solidFill>
-                          <a:latin typeface="Golos Text" pitchFamily="34" charset="0"/>
-                          <a:ea typeface="Golos Text" pitchFamily="34" charset="-122"/>
-                          <a:cs typeface="Golos Text" pitchFamily="34" charset="-120"/>
+                          <a:latin typeface="Arial" pitchFamily="34" charset="0"/>
+                          <a:ea typeface="Arial" pitchFamily="34" charset="-122"/>
+                          <a:cs typeface="Arial" pitchFamily="34" charset="-120"/>
                         </a:rPr>
                         <a:t>Сформулировать гипотезы</a:t>
                       </a:r>
                       <a:endParaRPr lang="en-US" sz="1200" dirty="0">
-                        <a:latin typeface="Golos Text" charset="0"/>
-                        <a:ea typeface="Golos Text" charset="0"/>
-                        <a:cs typeface="Golos Text" charset="0"/>
+                        <a:latin typeface="Arial" charset="0"/>
+                        <a:ea typeface="Arial" charset="0"/>
+                        <a:cs typeface="Arial" charset="0"/>
                       </a:endParaRPr>
                     </a:p>
                   </a:txBody>
@@ -4327,16 +4327,16 @@
                           <a:solidFill>
                             <a:srgbClr val="19003C"/>
                           </a:solidFill>
-                          <a:latin typeface="Golos Text" pitchFamily="34" charset="0"/>
-                          <a:ea typeface="Golos Text" pitchFamily="34" charset="-122"/>
-                          <a:cs typeface="Golos Text" pitchFamily="34" charset="-120"/>
+                          <a:latin typeface="Arial" pitchFamily="34" charset="0"/>
+                          <a:ea typeface="Arial" pitchFamily="34" charset="-122"/>
+                          <a:cs typeface="Arial" pitchFamily="34" charset="-120"/>
                         </a:rPr>
                         <a:t>технолог</a:t>
                       </a:r>
                       <a:endParaRPr lang="en-US" sz="1200" dirty="0">
-                        <a:latin typeface="Golos Text" charset="0"/>
-                        <a:ea typeface="Golos Text" charset="0"/>
-                        <a:cs typeface="Golos Text" charset="0"/>
+                        <a:latin typeface="Arial" charset="0"/>
+                        <a:ea typeface="Arial" charset="0"/>
+                        <a:cs typeface="Arial" charset="0"/>
                       </a:endParaRPr>
                     </a:p>
                   </a:txBody>
@@ -4392,16 +4392,16 @@
                           <a:solidFill>
                             <a:srgbClr val="19003C"/>
                           </a:solidFill>
-                          <a:latin typeface="Golos Text" pitchFamily="34" charset="0"/>
-                          <a:ea typeface="Golos Text" pitchFamily="34" charset="-122"/>
-                          <a:cs typeface="Golos Text" pitchFamily="34" charset="-120"/>
+                          <a:latin typeface="Arial" pitchFamily="34" charset="0"/>
+                          <a:ea typeface="Arial" pitchFamily="34" charset="-122"/>
+                          <a:cs typeface="Arial" pitchFamily="34" charset="-120"/>
                         </a:rPr>
                         <a:t>60</a:t>
                       </a:r>
                       <a:endParaRPr lang="en-US" sz="1200" dirty="0">
-                        <a:latin typeface="Golos Text" charset="0"/>
-                        <a:ea typeface="Golos Text" charset="0"/>
-                        <a:cs typeface="Golos Text" charset="0"/>
+                        <a:latin typeface="Arial" charset="0"/>
+                        <a:ea typeface="Arial" charset="0"/>
+                        <a:cs typeface="Arial" charset="0"/>
                       </a:endParaRPr>
                     </a:p>
                   </a:txBody>
@@ -4457,16 +4457,16 @@
                           <a:solidFill>
                             <a:srgbClr val="19003C"/>
                           </a:solidFill>
-                          <a:latin typeface="Golos Text" pitchFamily="34" charset="0"/>
-                          <a:ea typeface="Golos Text" pitchFamily="34" charset="-122"/>
-                          <a:cs typeface="Golos Text" pitchFamily="34" charset="-120"/>
+                          <a:latin typeface="Arial" pitchFamily="34" charset="0"/>
+                          <a:ea typeface="Arial" pitchFamily="34" charset="-122"/>
+                          <a:cs typeface="Arial" pitchFamily="34" charset="-120"/>
                         </a:rPr>
                         <a:t>2.3</a:t>
                       </a:r>
                       <a:endParaRPr lang="en-US" sz="1200" dirty="0">
-                        <a:latin typeface="Golos Text" charset="0"/>
-                        <a:ea typeface="Golos Text" charset="0"/>
-                        <a:cs typeface="Golos Text" charset="0"/>
+                        <a:latin typeface="Arial" charset="0"/>
+                        <a:ea typeface="Arial" charset="0"/>
+                        <a:cs typeface="Arial" charset="0"/>
                       </a:endParaRPr>
                     </a:p>
                   </a:txBody>
@@ -4522,16 +4522,16 @@
                           <a:solidFill>
                             <a:srgbClr val="19003C"/>
                           </a:solidFill>
-                          <a:latin typeface="Golos Text" pitchFamily="34" charset="0"/>
-                          <a:ea typeface="Golos Text" pitchFamily="34" charset="-122"/>
-                          <a:cs typeface="Golos Text" pitchFamily="34" charset="-120"/>
+                          <a:latin typeface="Arial" pitchFamily="34" charset="0"/>
+                          <a:ea typeface="Arial" pitchFamily="34" charset="-122"/>
+                          <a:cs typeface="Arial" pitchFamily="34" charset="-120"/>
                         </a:rPr>
                         <a:t>138</a:t>
                       </a:r>
                       <a:endParaRPr lang="en-US" sz="1200" dirty="0">
-                        <a:latin typeface="Golos Text" charset="0"/>
-                        <a:ea typeface="Golos Text" charset="0"/>
-                        <a:cs typeface="Golos Text" charset="0"/>
+                        <a:latin typeface="Arial" charset="0"/>
+                        <a:ea typeface="Arial" charset="0"/>
+                        <a:cs typeface="Arial" charset="0"/>
                       </a:endParaRPr>
                     </a:p>
                   </a:txBody>
@@ -4589,16 +4589,16 @@
                           <a:solidFill>
                             <a:srgbClr val="19003C"/>
                           </a:solidFill>
-                          <a:latin typeface="Golos Text" pitchFamily="34" charset="0"/>
-                          <a:ea typeface="Golos Text" pitchFamily="34" charset="-122"/>
-                          <a:cs typeface="Golos Text" pitchFamily="34" charset="-120"/>
+                          <a:latin typeface="Arial" pitchFamily="34" charset="0"/>
+                          <a:ea typeface="Arial" pitchFamily="34" charset="-122"/>
+                          <a:cs typeface="Arial" pitchFamily="34" charset="-120"/>
                         </a:rPr>
                         <a:t>4</a:t>
                       </a:r>
                       <a:endParaRPr lang="en-US" sz="1200" dirty="0">
-                        <a:latin typeface="Golos Text" charset="0"/>
-                        <a:ea typeface="Golos Text" charset="0"/>
-                        <a:cs typeface="Golos Text" charset="0"/>
+                        <a:latin typeface="Arial" charset="0"/>
+                        <a:ea typeface="Arial" charset="0"/>
+                        <a:cs typeface="Arial" charset="0"/>
                       </a:endParaRPr>
                     </a:p>
                   </a:txBody>
@@ -4657,16 +4657,16 @@
                           <a:solidFill>
                             <a:srgbClr val="19003C"/>
                           </a:solidFill>
-                          <a:latin typeface="Golos Text" pitchFamily="34" charset="0"/>
-                          <a:ea typeface="Golos Text" pitchFamily="34" charset="-122"/>
-                          <a:cs typeface="Golos Text" pitchFamily="34" charset="-120"/>
+                          <a:latin typeface="Arial" pitchFamily="34" charset="0"/>
+                          <a:ea typeface="Arial" pitchFamily="34" charset="-122"/>
+                          <a:cs typeface="Arial" pitchFamily="34" charset="-120"/>
                         </a:rPr>
                         <a:t>Проверить гипотезы расчётом в ИМА</a:t>
                       </a:r>
                       <a:endParaRPr lang="en-US" sz="1200" dirty="0">
-                        <a:latin typeface="Golos Text" charset="0"/>
-                        <a:ea typeface="Golos Text" charset="0"/>
-                        <a:cs typeface="Golos Text" charset="0"/>
+                        <a:latin typeface="Arial" charset="0"/>
+                        <a:ea typeface="Arial" charset="0"/>
+                        <a:cs typeface="Arial" charset="0"/>
                       </a:endParaRPr>
                     </a:p>
                   </a:txBody>
@@ -4725,16 +4725,16 @@
                           <a:solidFill>
                             <a:srgbClr val="19003C"/>
                           </a:solidFill>
-                          <a:latin typeface="Golos Text" pitchFamily="34" charset="0"/>
-                          <a:ea typeface="Golos Text" pitchFamily="34" charset="-122"/>
-                          <a:cs typeface="Golos Text" pitchFamily="34" charset="-120"/>
+                          <a:latin typeface="Arial" pitchFamily="34" charset="0"/>
+                          <a:ea typeface="Arial" pitchFamily="34" charset="-122"/>
+                          <a:cs typeface="Arial" pitchFamily="34" charset="-120"/>
                         </a:rPr>
                         <a:t>инженер-моделист</a:t>
                       </a:r>
                       <a:endParaRPr lang="en-US" sz="1200" dirty="0">
-                        <a:latin typeface="Golos Text" charset="0"/>
-                        <a:ea typeface="Golos Text" charset="0"/>
-                        <a:cs typeface="Golos Text" charset="0"/>
+                        <a:latin typeface="Arial" charset="0"/>
+                        <a:ea typeface="Arial" charset="0"/>
+                        <a:cs typeface="Arial" charset="0"/>
                       </a:endParaRPr>
                     </a:p>
                   </a:txBody>
@@ -4793,16 +4793,16 @@
                           <a:solidFill>
                             <a:srgbClr val="19003C"/>
                           </a:solidFill>
-                          <a:latin typeface="Golos Text" pitchFamily="34" charset="0"/>
-                          <a:ea typeface="Golos Text" pitchFamily="34" charset="-122"/>
-                          <a:cs typeface="Golos Text" pitchFamily="34" charset="-120"/>
+                          <a:latin typeface="Arial" pitchFamily="34" charset="0"/>
+                          <a:ea typeface="Arial" pitchFamily="34" charset="-122"/>
+                          <a:cs typeface="Arial" pitchFamily="34" charset="-120"/>
                         </a:rPr>
                         <a:t>120</a:t>
                       </a:r>
                       <a:endParaRPr lang="en-US" sz="1200" dirty="0">
-                        <a:latin typeface="Golos Text" charset="0"/>
-                        <a:ea typeface="Golos Text" charset="0"/>
-                        <a:cs typeface="Golos Text" charset="0"/>
+                        <a:latin typeface="Arial" charset="0"/>
+                        <a:ea typeface="Arial" charset="0"/>
+                        <a:cs typeface="Arial" charset="0"/>
                       </a:endParaRPr>
                     </a:p>
                   </a:txBody>
@@ -4861,16 +4861,16 @@
                           <a:solidFill>
                             <a:srgbClr val="19003C"/>
                           </a:solidFill>
-                          <a:latin typeface="Golos Text" pitchFamily="34" charset="0"/>
-                          <a:ea typeface="Golos Text" pitchFamily="34" charset="-122"/>
-                          <a:cs typeface="Golos Text" pitchFamily="34" charset="-120"/>
+                          <a:latin typeface="Arial" pitchFamily="34" charset="0"/>
+                          <a:ea typeface="Arial" pitchFamily="34" charset="-122"/>
+                          <a:cs typeface="Arial" pitchFamily="34" charset="-120"/>
                         </a:rPr>
                         <a:t>2.3</a:t>
                       </a:r>
                       <a:endParaRPr lang="en-US" sz="1200" dirty="0">
-                        <a:latin typeface="Golos Text" charset="0"/>
-                        <a:ea typeface="Golos Text" charset="0"/>
-                        <a:cs typeface="Golos Text" charset="0"/>
+                        <a:latin typeface="Arial" charset="0"/>
+                        <a:ea typeface="Arial" charset="0"/>
+                        <a:cs typeface="Arial" charset="0"/>
                       </a:endParaRPr>
                     </a:p>
                   </a:txBody>
@@ -4929,16 +4929,16 @@
                           <a:solidFill>
                             <a:srgbClr val="19003C"/>
                           </a:solidFill>
-                          <a:latin typeface="Golos Text" pitchFamily="34" charset="0"/>
-                          <a:ea typeface="Golos Text" pitchFamily="34" charset="-122"/>
-                          <a:cs typeface="Golos Text" pitchFamily="34" charset="-120"/>
+                          <a:latin typeface="Arial" pitchFamily="34" charset="0"/>
+                          <a:ea typeface="Arial" pitchFamily="34" charset="-122"/>
+                          <a:cs typeface="Arial" pitchFamily="34" charset="-120"/>
                         </a:rPr>
                         <a:t>276</a:t>
                       </a:r>
                       <a:endParaRPr lang="en-US" sz="1200" dirty="0">
-                        <a:latin typeface="Golos Text" charset="0"/>
-                        <a:ea typeface="Golos Text" charset="0"/>
-                        <a:cs typeface="Golos Text" charset="0"/>
+                        <a:latin typeface="Arial" charset="0"/>
+                        <a:ea typeface="Arial" charset="0"/>
+                        <a:cs typeface="Arial" charset="0"/>
                       </a:endParaRPr>
                     </a:p>
                   </a:txBody>
@@ -4999,16 +4999,16 @@
                           <a:solidFill>
                             <a:srgbClr val="19003C"/>
                           </a:solidFill>
-                          <a:latin typeface="Golos Text" pitchFamily="34" charset="0"/>
-                          <a:ea typeface="Golos Text" pitchFamily="34" charset="-122"/>
-                          <a:cs typeface="Golos Text" pitchFamily="34" charset="-120"/>
+                          <a:latin typeface="Arial" pitchFamily="34" charset="0"/>
+                          <a:ea typeface="Arial" pitchFamily="34" charset="-122"/>
+                          <a:cs typeface="Arial" pitchFamily="34" charset="-120"/>
                         </a:rPr>
                         <a:t>5</a:t>
                       </a:r>
                       <a:endParaRPr lang="en-US" sz="1200" dirty="0">
-                        <a:latin typeface="Golos Text" charset="0"/>
-                        <a:ea typeface="Golos Text" charset="0"/>
-                        <a:cs typeface="Golos Text" charset="0"/>
+                        <a:latin typeface="Arial" charset="0"/>
+                        <a:ea typeface="Arial" charset="0"/>
+                        <a:cs typeface="Arial" charset="0"/>
                       </a:endParaRPr>
                     </a:p>
                   </a:txBody>
@@ -5067,16 +5067,16 @@
                           <a:solidFill>
                             <a:srgbClr val="19003C"/>
                           </a:solidFill>
-                          <a:latin typeface="Golos Text" pitchFamily="34" charset="0"/>
-                          <a:ea typeface="Golos Text" pitchFamily="34" charset="-122"/>
-                          <a:cs typeface="Golos Text" pitchFamily="34" charset="-120"/>
+                          <a:latin typeface="Arial" pitchFamily="34" charset="0"/>
+                          <a:ea typeface="Arial" pitchFamily="34" charset="-122"/>
+                          <a:cs typeface="Arial" pitchFamily="34" charset="-120"/>
                         </a:rPr>
                         <a:t>Рассчитать режим куста и утвердить</a:t>
                       </a:r>
                       <a:endParaRPr lang="en-US" sz="1200" dirty="0">
-                        <a:latin typeface="Golos Text" charset="0"/>
-                        <a:ea typeface="Golos Text" charset="0"/>
-                        <a:cs typeface="Golos Text" charset="0"/>
+                        <a:latin typeface="Arial" charset="0"/>
+                        <a:ea typeface="Arial" charset="0"/>
+                        <a:cs typeface="Arial" charset="0"/>
                       </a:endParaRPr>
                     </a:p>
                   </a:txBody>
@@ -5135,16 +5135,16 @@
                           <a:solidFill>
                             <a:srgbClr val="19003C"/>
                           </a:solidFill>
-                          <a:latin typeface="Golos Text" pitchFamily="34" charset="0"/>
-                          <a:ea typeface="Golos Text" pitchFamily="34" charset="-122"/>
-                          <a:cs typeface="Golos Text" pitchFamily="34" charset="-120"/>
+                          <a:latin typeface="Arial" pitchFamily="34" charset="0"/>
+                          <a:ea typeface="Arial" pitchFamily="34" charset="-122"/>
+                          <a:cs typeface="Arial" pitchFamily="34" charset="-120"/>
                         </a:rPr>
                         <a:t>моделист, технолог</a:t>
                       </a:r>
                       <a:endParaRPr lang="en-US" sz="1200" dirty="0">
-                        <a:latin typeface="Golos Text" charset="0"/>
-                        <a:ea typeface="Golos Text" charset="0"/>
-                        <a:cs typeface="Golos Text" charset="0"/>
+                        <a:latin typeface="Arial" charset="0"/>
+                        <a:ea typeface="Arial" charset="0"/>
+                        <a:cs typeface="Arial" charset="0"/>
                       </a:endParaRPr>
                     </a:p>
                   </a:txBody>
@@ -5203,16 +5203,16 @@
                           <a:solidFill>
                             <a:srgbClr val="19003C"/>
                           </a:solidFill>
-                          <a:latin typeface="Golos Text" pitchFamily="34" charset="0"/>
-                          <a:ea typeface="Golos Text" pitchFamily="34" charset="-122"/>
-                          <a:cs typeface="Golos Text" pitchFamily="34" charset="-120"/>
+                          <a:latin typeface="Arial" pitchFamily="34" charset="0"/>
+                          <a:ea typeface="Arial" pitchFamily="34" charset="-122"/>
+                          <a:cs typeface="Arial" pitchFamily="34" charset="-120"/>
                         </a:rPr>
                         <a:t>120</a:t>
                       </a:r>
                       <a:endParaRPr lang="en-US" sz="1200" dirty="0">
-                        <a:latin typeface="Golos Text" charset="0"/>
-                        <a:ea typeface="Golos Text" charset="0"/>
-                        <a:cs typeface="Golos Text" charset="0"/>
+                        <a:latin typeface="Arial" charset="0"/>
+                        <a:ea typeface="Arial" charset="0"/>
+                        <a:cs typeface="Arial" charset="0"/>
                       </a:endParaRPr>
                     </a:p>
                   </a:txBody>
@@ -5271,16 +5271,16 @@
                           <a:solidFill>
                             <a:srgbClr val="19003C"/>
                           </a:solidFill>
-                          <a:latin typeface="Golos Text" pitchFamily="34" charset="0"/>
-                          <a:ea typeface="Golos Text" pitchFamily="34" charset="-122"/>
-                          <a:cs typeface="Golos Text" pitchFamily="34" charset="-120"/>
+                          <a:latin typeface="Arial" pitchFamily="34" charset="0"/>
+                          <a:ea typeface="Arial" pitchFamily="34" charset="-122"/>
+                          <a:cs typeface="Arial" pitchFamily="34" charset="-120"/>
                         </a:rPr>
                         <a:t>2.3</a:t>
                       </a:r>
                       <a:endParaRPr lang="en-US" sz="1200" dirty="0">
-                        <a:latin typeface="Golos Text" charset="0"/>
-                        <a:ea typeface="Golos Text" charset="0"/>
-                        <a:cs typeface="Golos Text" charset="0"/>
+                        <a:latin typeface="Arial" charset="0"/>
+                        <a:ea typeface="Arial" charset="0"/>
+                        <a:cs typeface="Arial" charset="0"/>
                       </a:endParaRPr>
                     </a:p>
                   </a:txBody>
@@ -5339,16 +5339,16 @@
                           <a:solidFill>
                             <a:srgbClr val="19003C"/>
                           </a:solidFill>
-                          <a:latin typeface="Golos Text" pitchFamily="34" charset="0"/>
-                          <a:ea typeface="Golos Text" pitchFamily="34" charset="-122"/>
-                          <a:cs typeface="Golos Text" pitchFamily="34" charset="-120"/>
+                          <a:latin typeface="Arial" pitchFamily="34" charset="0"/>
+                          <a:ea typeface="Arial" pitchFamily="34" charset="-122"/>
+                          <a:cs typeface="Arial" pitchFamily="34" charset="-120"/>
                         </a:rPr>
                         <a:t>276</a:t>
                       </a:r>
                       <a:endParaRPr lang="en-US" sz="1200" dirty="0">
-                        <a:latin typeface="Golos Text" charset="0"/>
-                        <a:ea typeface="Golos Text" charset="0"/>
-                        <a:cs typeface="Golos Text" charset="0"/>
+                        <a:latin typeface="Arial" charset="0"/>
+                        <a:ea typeface="Arial" charset="0"/>
+                        <a:cs typeface="Arial" charset="0"/>
                       </a:endParaRPr>
                     </a:p>
                   </a:txBody>
@@ -5409,16 +5409,16 @@
                           <a:solidFill>
                             <a:srgbClr val="19003C"/>
                           </a:solidFill>
-                          <a:latin typeface="Golos Text" pitchFamily="34" charset="0"/>
-                          <a:ea typeface="Golos Text" pitchFamily="34" charset="-122"/>
-                          <a:cs typeface="Golos Text" pitchFamily="34" charset="-120"/>
+                          <a:latin typeface="Arial" pitchFamily="34" charset="0"/>
+                          <a:ea typeface="Arial" pitchFamily="34" charset="-122"/>
+                          <a:cs typeface="Arial" pitchFamily="34" charset="-120"/>
                         </a:rPr>
                         <a:t>6</a:t>
                       </a:r>
                       <a:endParaRPr lang="en-US" sz="1200" dirty="0">
-                        <a:latin typeface="Golos Text" charset="0"/>
-                        <a:ea typeface="Golos Text" charset="0"/>
-                        <a:cs typeface="Golos Text" charset="0"/>
+                        <a:latin typeface="Arial" charset="0"/>
+                        <a:ea typeface="Arial" charset="0"/>
+                        <a:cs typeface="Arial" charset="0"/>
                       </a:endParaRPr>
                     </a:p>
                   </a:txBody>
@@ -5474,16 +5474,16 @@
                           <a:solidFill>
                             <a:srgbClr val="19003C"/>
                           </a:solidFill>
-                          <a:latin typeface="Golos Text" pitchFamily="34" charset="0"/>
-                          <a:ea typeface="Golos Text" pitchFamily="34" charset="-122"/>
-                          <a:cs typeface="Golos Text" pitchFamily="34" charset="-120"/>
+                          <a:latin typeface="Arial" pitchFamily="34" charset="0"/>
+                          <a:ea typeface="Arial" pitchFamily="34" charset="-122"/>
+                          <a:cs typeface="Arial" pitchFamily="34" charset="-120"/>
                         </a:rPr>
                         <a:t>Согласовать с цехом, внести уставки</a:t>
                       </a:r>
                       <a:endParaRPr lang="en-US" sz="1200" dirty="0">
-                        <a:latin typeface="Golos Text" charset="0"/>
-                        <a:ea typeface="Golos Text" charset="0"/>
-                        <a:cs typeface="Golos Text" charset="0"/>
+                        <a:latin typeface="Arial" charset="0"/>
+                        <a:ea typeface="Arial" charset="0"/>
+                        <a:cs typeface="Arial" charset="0"/>
                       </a:endParaRPr>
                     </a:p>
                   </a:txBody>
@@ -5539,16 +5539,16 @@
                           <a:solidFill>
                             <a:srgbClr val="19003C"/>
                           </a:solidFill>
-                          <a:latin typeface="Golos Text" pitchFamily="34" charset="0"/>
-                          <a:ea typeface="Golos Text" pitchFamily="34" charset="-122"/>
-                          <a:cs typeface="Golos Text" pitchFamily="34" charset="-120"/>
+                          <a:latin typeface="Arial" pitchFamily="34" charset="0"/>
+                          <a:ea typeface="Arial" pitchFamily="34" charset="-122"/>
+                          <a:cs typeface="Arial" pitchFamily="34" charset="-120"/>
                         </a:rPr>
                         <a:t>начальник ЦДНГ</a:t>
                       </a:r>
                       <a:endParaRPr lang="en-US" sz="1200" dirty="0">
-                        <a:latin typeface="Golos Text" charset="0"/>
-                        <a:ea typeface="Golos Text" charset="0"/>
-                        <a:cs typeface="Golos Text" charset="0"/>
+                        <a:latin typeface="Arial" charset="0"/>
+                        <a:ea typeface="Arial" charset="0"/>
+                        <a:cs typeface="Arial" charset="0"/>
                       </a:endParaRPr>
                     </a:p>
                   </a:txBody>
@@ -5604,16 +5604,16 @@
                           <a:solidFill>
                             <a:srgbClr val="19003C"/>
                           </a:solidFill>
-                          <a:latin typeface="Golos Text" pitchFamily="34" charset="0"/>
-                          <a:ea typeface="Golos Text" pitchFamily="34" charset="-122"/>
-                          <a:cs typeface="Golos Text" pitchFamily="34" charset="-120"/>
+                          <a:latin typeface="Arial" pitchFamily="34" charset="0"/>
+                          <a:ea typeface="Arial" pitchFamily="34" charset="-122"/>
+                          <a:cs typeface="Arial" pitchFamily="34" charset="-120"/>
                         </a:rPr>
                         <a:t>20</a:t>
                       </a:r>
                       <a:endParaRPr lang="en-US" sz="1200" dirty="0">
-                        <a:latin typeface="Golos Text" charset="0"/>
-                        <a:ea typeface="Golos Text" charset="0"/>
-                        <a:cs typeface="Golos Text" charset="0"/>
+                        <a:latin typeface="Arial" charset="0"/>
+                        <a:ea typeface="Arial" charset="0"/>
+                        <a:cs typeface="Arial" charset="0"/>
                       </a:endParaRPr>
                     </a:p>
                   </a:txBody>
@@ -5669,16 +5669,16 @@
                           <a:solidFill>
                             <a:srgbClr val="19003C"/>
                           </a:solidFill>
-                          <a:latin typeface="Golos Text" pitchFamily="34" charset="0"/>
-                          <a:ea typeface="Golos Text" pitchFamily="34" charset="-122"/>
-                          <a:cs typeface="Golos Text" pitchFamily="34" charset="-120"/>
+                          <a:latin typeface="Arial" pitchFamily="34" charset="0"/>
+                          <a:ea typeface="Arial" pitchFamily="34" charset="-122"/>
+                          <a:cs typeface="Arial" pitchFamily="34" charset="-120"/>
                         </a:rPr>
                         <a:t>2.3</a:t>
                       </a:r>
                       <a:endParaRPr lang="en-US" sz="1200" dirty="0">
-                        <a:latin typeface="Golos Text" charset="0"/>
-                        <a:ea typeface="Golos Text" charset="0"/>
-                        <a:cs typeface="Golos Text" charset="0"/>
+                        <a:latin typeface="Arial" charset="0"/>
+                        <a:ea typeface="Arial" charset="0"/>
+                        <a:cs typeface="Arial" charset="0"/>
                       </a:endParaRPr>
                     </a:p>
                   </a:txBody>
@@ -5734,16 +5734,16 @@
                           <a:solidFill>
                             <a:srgbClr val="19003C"/>
                           </a:solidFill>
-                          <a:latin typeface="Golos Text" pitchFamily="34" charset="0"/>
-                          <a:ea typeface="Golos Text" pitchFamily="34" charset="-122"/>
-                          <a:cs typeface="Golos Text" pitchFamily="34" charset="-120"/>
+                          <a:latin typeface="Arial" pitchFamily="34" charset="0"/>
+                          <a:ea typeface="Arial" pitchFamily="34" charset="-122"/>
+                          <a:cs typeface="Arial" pitchFamily="34" charset="-120"/>
                         </a:rPr>
                         <a:t>46</a:t>
                       </a:r>
                       <a:endParaRPr lang="en-US" sz="1200" dirty="0">
-                        <a:latin typeface="Golos Text" charset="0"/>
-                        <a:ea typeface="Golos Text" charset="0"/>
-                        <a:cs typeface="Golos Text" charset="0"/>
+                        <a:latin typeface="Arial" charset="0"/>
+                        <a:ea typeface="Arial" charset="0"/>
+                        <a:cs typeface="Arial" charset="0"/>
                       </a:endParaRPr>
                     </a:p>
                   </a:txBody>
@@ -5801,16 +5801,16 @@
                           <a:solidFill>
                             <a:srgbClr val="19003C"/>
                           </a:solidFill>
-                          <a:latin typeface="Golos Text" pitchFamily="34" charset="0"/>
-                          <a:ea typeface="Golos Text" pitchFamily="34" charset="-122"/>
-                          <a:cs typeface="Golos Text" pitchFamily="34" charset="-120"/>
+                          <a:latin typeface="Arial" pitchFamily="34" charset="0"/>
+                          <a:ea typeface="Arial" pitchFamily="34" charset="-122"/>
+                          <a:cs typeface="Arial" pitchFamily="34" charset="-120"/>
                         </a:rPr>
                         <a:t>7</a:t>
                       </a:r>
                       <a:endParaRPr lang="en-US" sz="1200" dirty="0">
-                        <a:latin typeface="Golos Text" charset="0"/>
-                        <a:ea typeface="Golos Text" charset="0"/>
-                        <a:cs typeface="Golos Text" charset="0"/>
+                        <a:latin typeface="Arial" charset="0"/>
+                        <a:ea typeface="Arial" charset="0"/>
+                        <a:cs typeface="Arial" charset="0"/>
                       </a:endParaRPr>
                     </a:p>
                   </a:txBody>
@@ -5866,16 +5866,16 @@
                           <a:solidFill>
                             <a:srgbClr val="19003C"/>
                           </a:solidFill>
-                          <a:latin typeface="Golos Text" pitchFamily="34" charset="0"/>
-                          <a:ea typeface="Golos Text" pitchFamily="34" charset="-122"/>
-                          <a:cs typeface="Golos Text" pitchFamily="34" charset="-120"/>
+                          <a:latin typeface="Arial" pitchFamily="34" charset="0"/>
+                          <a:ea typeface="Arial" pitchFamily="34" charset="-122"/>
+                          <a:cs typeface="Arial" pitchFamily="34" charset="-120"/>
                         </a:rPr>
                         <a:t>Сравнить факт с прогнозом</a:t>
                       </a:r>
                       <a:endParaRPr lang="en-US" sz="1200" dirty="0">
-                        <a:latin typeface="Golos Text" charset="0"/>
-                        <a:ea typeface="Golos Text" charset="0"/>
-                        <a:cs typeface="Golos Text" charset="0"/>
+                        <a:latin typeface="Arial" charset="0"/>
+                        <a:ea typeface="Arial" charset="0"/>
+                        <a:cs typeface="Arial" charset="0"/>
                       </a:endParaRPr>
                     </a:p>
                   </a:txBody>
@@ -5931,16 +5931,16 @@
                           <a:solidFill>
                             <a:srgbClr val="19003C"/>
                           </a:solidFill>
-                          <a:latin typeface="Golos Text" pitchFamily="34" charset="0"/>
-                          <a:ea typeface="Golos Text" pitchFamily="34" charset="-122"/>
-                          <a:cs typeface="Golos Text" pitchFamily="34" charset="-120"/>
+                          <a:latin typeface="Arial" pitchFamily="34" charset="0"/>
+                          <a:ea typeface="Arial" pitchFamily="34" charset="-122"/>
+                          <a:cs typeface="Arial" pitchFamily="34" charset="-120"/>
                         </a:rPr>
                         <a:t>скрипт</a:t>
                       </a:r>
                       <a:endParaRPr lang="en-US" sz="1200" dirty="0">
-                        <a:latin typeface="Golos Text" charset="0"/>
-                        <a:ea typeface="Golos Text" charset="0"/>
-                        <a:cs typeface="Golos Text" charset="0"/>
+                        <a:latin typeface="Arial" charset="0"/>
+                        <a:ea typeface="Arial" charset="0"/>
+                        <a:cs typeface="Arial" charset="0"/>
                       </a:endParaRPr>
                     </a:p>
                   </a:txBody>
@@ -5996,16 +5996,16 @@
                           <a:solidFill>
                             <a:srgbClr val="19003C"/>
                           </a:solidFill>
-                          <a:latin typeface="Golos Text" pitchFamily="34" charset="0"/>
-                          <a:ea typeface="Golos Text" pitchFamily="34" charset="-122"/>
-                          <a:cs typeface="Golos Text" pitchFamily="34" charset="-120"/>
+                          <a:latin typeface="Arial" pitchFamily="34" charset="0"/>
+                          <a:ea typeface="Arial" pitchFamily="34" charset="-122"/>
+                          <a:cs typeface="Arial" pitchFamily="34" charset="-120"/>
                         </a:rPr>
                         <a:t>15</a:t>
                       </a:r>
                       <a:endParaRPr lang="en-US" sz="1200" dirty="0">
-                        <a:latin typeface="Golos Text" charset="0"/>
-                        <a:ea typeface="Golos Text" charset="0"/>
-                        <a:cs typeface="Golos Text" charset="0"/>
+                        <a:latin typeface="Arial" charset="0"/>
+                        <a:ea typeface="Arial" charset="0"/>
+                        <a:cs typeface="Arial" charset="0"/>
                       </a:endParaRPr>
                     </a:p>
                   </a:txBody>
@@ -6061,16 +6061,16 @@
                           <a:solidFill>
                             <a:srgbClr val="19003C"/>
                           </a:solidFill>
-                          <a:latin typeface="Golos Text" pitchFamily="34" charset="0"/>
-                          <a:ea typeface="Golos Text" pitchFamily="34" charset="-122"/>
-                          <a:cs typeface="Golos Text" pitchFamily="34" charset="-120"/>
+                          <a:latin typeface="Arial" pitchFamily="34" charset="0"/>
+                          <a:ea typeface="Arial" pitchFamily="34" charset="-122"/>
+                          <a:cs typeface="Arial" pitchFamily="34" charset="-120"/>
                         </a:rPr>
                         <a:t>5</a:t>
                       </a:r>
                       <a:endParaRPr lang="en-US" sz="1200" dirty="0">
-                        <a:latin typeface="Golos Text" charset="0"/>
-                        <a:ea typeface="Golos Text" charset="0"/>
-                        <a:cs typeface="Golos Text" charset="0"/>
+                        <a:latin typeface="Arial" charset="0"/>
+                        <a:ea typeface="Arial" charset="0"/>
+                        <a:cs typeface="Arial" charset="0"/>
                       </a:endParaRPr>
                     </a:p>
                   </a:txBody>
@@ -6126,16 +6126,16 @@
                           <a:solidFill>
                             <a:srgbClr val="19003C"/>
                           </a:solidFill>
-                          <a:latin typeface="Golos Text" pitchFamily="34" charset="0"/>
-                          <a:ea typeface="Golos Text" pitchFamily="34" charset="-122"/>
-                          <a:cs typeface="Golos Text" pitchFamily="34" charset="-120"/>
+                          <a:latin typeface="Arial" pitchFamily="34" charset="0"/>
+                          <a:ea typeface="Arial" pitchFamily="34" charset="-122"/>
+                          <a:cs typeface="Arial" pitchFamily="34" charset="-120"/>
                         </a:rPr>
                         <a:t>75</a:t>
                       </a:r>
                       <a:endParaRPr lang="en-US" sz="1200" dirty="0">
-                        <a:latin typeface="Golos Text" charset="0"/>
-                        <a:ea typeface="Golos Text" charset="0"/>
-                        <a:cs typeface="Golos Text" charset="0"/>
+                        <a:latin typeface="Arial" charset="0"/>
+                        <a:ea typeface="Arial" charset="0"/>
+                        <a:cs typeface="Arial" charset="0"/>
                       </a:endParaRPr>
                     </a:p>
                   </a:txBody>
@@ -6234,9 +6234,9 @@
                 <a:solidFill>
                   <a:srgbClr val="FFFFFF"/>
                 </a:solidFill>
-                <a:latin typeface="Golos Text DemiBold" pitchFamily="34" charset="0"/>
-                <a:ea typeface="Golos Text DemiBold" pitchFamily="34" charset="-122"/>
-                <a:cs typeface="Golos Text DemiBold" pitchFamily="34" charset="-120"/>
+                <a:latin typeface="Arial" pitchFamily="34" charset="0"/>
+                <a:ea typeface="Arial" pitchFamily="34" charset="-122"/>
+                <a:cs typeface="Arial" pitchFamily="34" charset="-120"/>
               </a:rPr>
               <a:t>Шаги 4–5: 552 из 1 211 мин в неделю (46 %) и 10 из 18 ч задержки действия</a:t>
             </a:r>
@@ -6273,9 +6273,9 @@
                 <a:solidFill>
                   <a:srgbClr val="A7A6A6"/>
                 </a:solidFill>
-                <a:latin typeface="Golos Text" pitchFamily="34" charset="0"/>
-                <a:ea typeface="Golos Text" pitchFamily="34" charset="-122"/>
-                <a:cs typeface="Golos Text" pitchFamily="34" charset="-120"/>
+                <a:latin typeface="Arial" pitchFamily="34" charset="0"/>
+                <a:ea typeface="Arial" pitchFamily="34" charset="-122"/>
+                <a:cs typeface="Arial" pitchFamily="34" charset="-120"/>
               </a:rPr>
               <a:t>Минуты и частота — таблица части 1 (экспертная оценка), сведены с 10 ч аудита: 380 мин работы + 220 мин ожидания двухчасовки и начала разбора.</a:t>
             </a:r>
@@ -6388,9 +6388,9 @@
                 <a:solidFill>
                   <a:srgbClr val="A7A6A6"/>
                 </a:solidFill>
-                <a:latin typeface="Golos Text" pitchFamily="34" charset="0"/>
-                <a:ea typeface="Golos Text" pitchFamily="34" charset="-122"/>
-                <a:cs typeface="Golos Text" pitchFamily="34" charset="-120"/>
+                <a:latin typeface="Arial" pitchFamily="34" charset="0"/>
+                <a:ea typeface="Arial" pitchFamily="34" charset="-122"/>
+                <a:cs typeface="Arial" pitchFamily="34" charset="-120"/>
               </a:rPr>
               <a:t>4</a:t>
             </a:r>
@@ -6427,9 +6427,9 @@
                 <a:solidFill>
                   <a:srgbClr val="41008C"/>
                 </a:solidFill>
-                <a:latin typeface="Golos Text DemiBold" pitchFamily="34" charset="0"/>
-                <a:ea typeface="Golos Text DemiBold" pitchFamily="34" charset="-122"/>
-                <a:cs typeface="Golos Text DemiBold" pitchFamily="34" charset="-120"/>
+                <a:latin typeface="Arial" pitchFamily="34" charset="0"/>
+                <a:ea typeface="Arial" pitchFamily="34" charset="-122"/>
+                <a:cs typeface="Arial" pitchFamily="34" charset="-120"/>
               </a:rPr>
               <a:t>NS Digital</a:t>
             </a:r>
@@ -6441,9 +6441,9 @@
                 <a:solidFill>
                   <a:srgbClr val="19003C"/>
                 </a:solidFill>
-                <a:latin typeface="Golos Text DemiBold" pitchFamily="34" charset="0"/>
-                <a:ea typeface="Golos Text DemiBold" pitchFamily="34" charset="-122"/>
-                <a:cs typeface="Golos Text DemiBold" pitchFamily="34" charset="-120"/>
+                <a:latin typeface="Arial" pitchFamily="34" charset="0"/>
+                <a:ea typeface="Arial" pitchFamily="34" charset="-122"/>
+                <a:cs typeface="Arial" pitchFamily="34" charset="-120"/>
               </a:rPr>
               <a:t> / Как будет (To-Be)</a:t>
             </a:r>
@@ -6503,9 +6503,9 @@
                 <a:solidFill>
                   <a:srgbClr val="19003C"/>
                 </a:solidFill>
-                <a:latin typeface="Golos Text DemiBold" pitchFamily="34" charset="0"/>
-                <a:ea typeface="Golos Text DemiBold" pitchFamily="34" charset="-122"/>
-                <a:cs typeface="Golos Text DemiBold" pitchFamily="34" charset="-120"/>
+                <a:latin typeface="Arial" pitchFamily="34" charset="0"/>
+                <a:ea typeface="Arial" pitchFamily="34" charset="-122"/>
+                <a:cs typeface="Arial" pitchFamily="34" charset="-120"/>
               </a:rPr>
               <a:t>ЕЖЕЧАСНЫЙ КОНТРОЛЬ И РАСЧЁТ ПО СОБЫТИЮ; РЕШЕНИЕ ОСТАЁТСЯ ЗА ИНЖЕНЕРОМ</a:t>
             </a:r>
@@ -6562,9 +6562,9 @@
                 <a:solidFill>
                   <a:srgbClr val="41008C"/>
                 </a:solidFill>
-                <a:latin typeface="Golos Text DemiBold" pitchFamily="34" charset="0"/>
-                <a:ea typeface="Golos Text DemiBold" pitchFamily="34" charset="-122"/>
-                <a:cs typeface="Golos Text DemiBold" pitchFamily="34" charset="-120"/>
+                <a:latin typeface="Arial" pitchFamily="34" charset="0"/>
+                <a:ea typeface="Arial" pitchFamily="34" charset="-122"/>
+                <a:cs typeface="Arial" pitchFamily="34" charset="-120"/>
               </a:rPr>
               <a:t>Т1</a:t>
             </a:r>
@@ -6601,9 +6601,9 @@
                 <a:solidFill>
                   <a:srgbClr val="19003C"/>
                 </a:solidFill>
-                <a:latin typeface="Golos Text" pitchFamily="34" charset="0"/>
-                <a:ea typeface="Golos Text" pitchFamily="34" charset="-122"/>
-                <a:cs typeface="Golos Text" pitchFamily="34" charset="-120"/>
+                <a:latin typeface="Arial" pitchFamily="34" charset="0"/>
+                <a:ea typeface="Arial" pitchFamily="34" charset="-122"/>
+                <a:cs typeface="Arial" pitchFamily="34" charset="-120"/>
               </a:rPr>
               <a:t>Принять и проверить замеры</a:t>
             </a:r>
@@ -6640,9 +6640,9 @@
                 <a:solidFill>
                   <a:srgbClr val="A7A6A6"/>
                 </a:solidFill>
-                <a:latin typeface="Golos Text DemiBold" pitchFamily="34" charset="0"/>
-                <a:ea typeface="Golos Text DemiBold" pitchFamily="34" charset="-122"/>
-                <a:cs typeface="Golos Text DemiBold" pitchFamily="34" charset="-120"/>
+                <a:latin typeface="Arial" pitchFamily="34" charset="0"/>
+                <a:ea typeface="Arial" pitchFamily="34" charset="-122"/>
+                <a:cs typeface="Arial" pitchFamily="34" charset="-120"/>
               </a:rPr>
               <a:t>WORKFLOW</a:t>
             </a:r>
@@ -6699,9 +6699,9 @@
                 <a:solidFill>
                   <a:srgbClr val="41008C"/>
                 </a:solidFill>
-                <a:latin typeface="Golos Text DemiBold" pitchFamily="34" charset="0"/>
-                <a:ea typeface="Golos Text DemiBold" pitchFamily="34" charset="-122"/>
-                <a:cs typeface="Golos Text DemiBold" pitchFamily="34" charset="-120"/>
+                <a:latin typeface="Arial" pitchFamily="34" charset="0"/>
+                <a:ea typeface="Arial" pitchFamily="34" charset="-122"/>
+                <a:cs typeface="Arial" pitchFamily="34" charset="-120"/>
               </a:rPr>
               <a:t>Т2</a:t>
             </a:r>
@@ -6738,9 +6738,9 @@
                 <a:solidFill>
                   <a:srgbClr val="19003C"/>
                 </a:solidFill>
-                <a:latin typeface="Golos Text" pitchFamily="34" charset="0"/>
-                <a:ea typeface="Golos Text" pitchFamily="34" charset="-122"/>
-                <a:cs typeface="Golos Text" pitchFamily="34" charset="-120"/>
+                <a:latin typeface="Arial" pitchFamily="34" charset="0"/>
+                <a:ea typeface="Arial" pitchFamily="34" charset="-122"/>
+                <a:cs typeface="Arial" pitchFamily="34" charset="-120"/>
               </a:rPr>
               <a:t>Обнаружить отклонение</a:t>
             </a:r>
@@ -6777,9 +6777,9 @@
                 <a:solidFill>
                   <a:srgbClr val="A7A6A6"/>
                 </a:solidFill>
-                <a:latin typeface="Golos Text DemiBold" pitchFamily="34" charset="0"/>
-                <a:ea typeface="Golos Text DemiBold" pitchFamily="34" charset="-122"/>
-                <a:cs typeface="Golos Text DemiBold" pitchFamily="34" charset="-120"/>
+                <a:latin typeface="Arial" pitchFamily="34" charset="0"/>
+                <a:ea typeface="Arial" pitchFamily="34" charset="-122"/>
+                <a:cs typeface="Arial" pitchFamily="34" charset="-120"/>
               </a:rPr>
               <a:t>WORKFLOW</a:t>
             </a:r>
@@ -6836,9 +6836,9 @@
                 <a:solidFill>
                   <a:srgbClr val="FFFFFF"/>
                 </a:solidFill>
-                <a:latin typeface="Golos Text DemiBold" pitchFamily="34" charset="0"/>
-                <a:ea typeface="Golos Text DemiBold" pitchFamily="34" charset="-122"/>
-                <a:cs typeface="Golos Text DemiBold" pitchFamily="34" charset="-120"/>
+                <a:latin typeface="Arial" pitchFamily="34" charset="0"/>
+                <a:ea typeface="Arial" pitchFamily="34" charset="-122"/>
+                <a:cs typeface="Arial" pitchFamily="34" charset="-120"/>
               </a:rPr>
               <a:t>Т3</a:t>
             </a:r>
@@ -6875,9 +6875,9 @@
                 <a:solidFill>
                   <a:srgbClr val="19003C"/>
                 </a:solidFill>
-                <a:latin typeface="Golos Text" pitchFamily="34" charset="0"/>
-                <a:ea typeface="Golos Text" pitchFamily="34" charset="-122"/>
-                <a:cs typeface="Golos Text" pitchFamily="34" charset="-120"/>
+                <a:latin typeface="Arial" pitchFamily="34" charset="0"/>
+                <a:ea typeface="Arial" pitchFamily="34" charset="-122"/>
+                <a:cs typeface="Arial" pitchFamily="34" charset="-120"/>
               </a:rPr>
               <a:t>Диагноз: гипотезы + PROSPER</a:t>
             </a:r>
@@ -6914,9 +6914,9 @@
                 <a:solidFill>
                   <a:srgbClr val="41008C"/>
                 </a:solidFill>
-                <a:latin typeface="Golos Text DemiBold" pitchFamily="34" charset="0"/>
-                <a:ea typeface="Golos Text DemiBold" pitchFamily="34" charset="-122"/>
-                <a:cs typeface="Golos Text DemiBold" pitchFamily="34" charset="-120"/>
+                <a:latin typeface="Arial" pitchFamily="34" charset="0"/>
+                <a:ea typeface="Arial" pitchFamily="34" charset="-122"/>
+                <a:cs typeface="Arial" pitchFamily="34" charset="-120"/>
               </a:rPr>
               <a:t>АГЕНТ</a:t>
             </a:r>
@@ -6973,9 +6973,9 @@
                 <a:solidFill>
                   <a:srgbClr val="FFFFFF"/>
                 </a:solidFill>
-                <a:latin typeface="Golos Text DemiBold" pitchFamily="34" charset="0"/>
-                <a:ea typeface="Golos Text DemiBold" pitchFamily="34" charset="-122"/>
-                <a:cs typeface="Golos Text DemiBold" pitchFamily="34" charset="-120"/>
+                <a:latin typeface="Arial" pitchFamily="34" charset="0"/>
+                <a:ea typeface="Arial" pitchFamily="34" charset="-122"/>
+                <a:cs typeface="Arial" pitchFamily="34" charset="-120"/>
               </a:rPr>
               <a:t>Т4</a:t>
             </a:r>
@@ -7012,9 +7012,9 @@
                 <a:solidFill>
                   <a:srgbClr val="19003C"/>
                 </a:solidFill>
-                <a:latin typeface="Golos Text" pitchFamily="34" charset="0"/>
-                <a:ea typeface="Golos Text" pitchFamily="34" charset="-122"/>
-                <a:cs typeface="Golos Text" pitchFamily="34" charset="-120"/>
+                <a:latin typeface="Arial" pitchFamily="34" charset="0"/>
+                <a:ea typeface="Arial" pitchFamily="34" charset="-122"/>
+                <a:cs typeface="Arial" pitchFamily="34" charset="-120"/>
               </a:rPr>
               <a:t>Компенсация: наборы + GAP</a:t>
             </a:r>
@@ -7051,9 +7051,9 @@
                 <a:solidFill>
                   <a:srgbClr val="41008C"/>
                 </a:solidFill>
-                <a:latin typeface="Golos Text DemiBold" pitchFamily="34" charset="0"/>
-                <a:ea typeface="Golos Text DemiBold" pitchFamily="34" charset="-122"/>
-                <a:cs typeface="Golos Text DemiBold" pitchFamily="34" charset="-120"/>
+                <a:latin typeface="Arial" pitchFamily="34" charset="0"/>
+                <a:ea typeface="Arial" pitchFamily="34" charset="-122"/>
+                <a:cs typeface="Arial" pitchFamily="34" charset="-120"/>
               </a:rPr>
               <a:t>АГЕНТ</a:t>
             </a:r>
@@ -7110,9 +7110,9 @@
                 <a:solidFill>
                   <a:srgbClr val="41008C"/>
                 </a:solidFill>
-                <a:latin typeface="Golos Text DemiBold" pitchFamily="34" charset="0"/>
-                <a:ea typeface="Golos Text DemiBold" pitchFamily="34" charset="-122"/>
-                <a:cs typeface="Golos Text DemiBold" pitchFamily="34" charset="-120"/>
+                <a:latin typeface="Arial" pitchFamily="34" charset="0"/>
+                <a:ea typeface="Arial" pitchFamily="34" charset="-122"/>
+                <a:cs typeface="Arial" pitchFamily="34" charset="-120"/>
               </a:rPr>
               <a:t>Т5</a:t>
             </a:r>
@@ -7149,9 +7149,9 @@
                 <a:solidFill>
                   <a:srgbClr val="19003C"/>
                 </a:solidFill>
-                <a:latin typeface="Golos Text" pitchFamily="34" charset="0"/>
-                <a:ea typeface="Golos Text" pitchFamily="34" charset="-122"/>
-                <a:cs typeface="Golos Text" pitchFamily="34" charset="-120"/>
+                <a:latin typeface="Arial" pitchFamily="34" charset="0"/>
+                <a:ea typeface="Arial" pitchFamily="34" charset="-122"/>
+                <a:cs typeface="Arial" pitchFamily="34" charset="-120"/>
               </a:rPr>
               <a:t>Утвердить / вернуть</a:t>
             </a:r>
@@ -7188,9 +7188,9 @@
                 <a:solidFill>
                   <a:srgbClr val="A7A6A6"/>
                 </a:solidFill>
-                <a:latin typeface="Golos Text DemiBold" pitchFamily="34" charset="0"/>
-                <a:ea typeface="Golos Text DemiBold" pitchFamily="34" charset="-122"/>
-                <a:cs typeface="Golos Text DemiBold" pitchFamily="34" charset="-120"/>
+                <a:latin typeface="Arial" pitchFamily="34" charset="0"/>
+                <a:ea typeface="Arial" pitchFamily="34" charset="-122"/>
+                <a:cs typeface="Arial" pitchFamily="34" charset="-120"/>
               </a:rPr>
               <a:t>ТЕХНОЛОГ</a:t>
             </a:r>
@@ -7247,9 +7247,9 @@
                 <a:solidFill>
                   <a:srgbClr val="41008C"/>
                 </a:solidFill>
-                <a:latin typeface="Golos Text DemiBold" pitchFamily="34" charset="0"/>
-                <a:ea typeface="Golos Text DemiBold" pitchFamily="34" charset="-122"/>
-                <a:cs typeface="Golos Text DemiBold" pitchFamily="34" charset="-120"/>
+                <a:latin typeface="Arial" pitchFamily="34" charset="0"/>
+                <a:ea typeface="Arial" pitchFamily="34" charset="-122"/>
+                <a:cs typeface="Arial" pitchFamily="34" charset="-120"/>
               </a:rPr>
               <a:t>Т6</a:t>
             </a:r>
@@ -7286,9 +7286,9 @@
                 <a:solidFill>
                   <a:srgbClr val="19003C"/>
                 </a:solidFill>
-                <a:latin typeface="Golos Text" pitchFamily="34" charset="0"/>
-                <a:ea typeface="Golos Text" pitchFamily="34" charset="-122"/>
-                <a:cs typeface="Golos Text" pitchFamily="34" charset="-120"/>
+                <a:latin typeface="Arial" pitchFamily="34" charset="0"/>
+                <a:ea typeface="Arial" pitchFamily="34" charset="-122"/>
+                <a:cs typeface="Arial" pitchFamily="34" charset="-120"/>
               </a:rPr>
               <a:t>Согласовать с цехом</a:t>
             </a:r>
@@ -7325,9 +7325,9 @@
                 <a:solidFill>
                   <a:srgbClr val="A7A6A6"/>
                 </a:solidFill>
-                <a:latin typeface="Golos Text DemiBold" pitchFamily="34" charset="0"/>
-                <a:ea typeface="Golos Text DemiBold" pitchFamily="34" charset="-122"/>
-                <a:cs typeface="Golos Text DemiBold" pitchFamily="34" charset="-120"/>
+                <a:latin typeface="Arial" pitchFamily="34" charset="0"/>
+                <a:ea typeface="Arial" pitchFamily="34" charset="-122"/>
+                <a:cs typeface="Arial" pitchFamily="34" charset="-120"/>
               </a:rPr>
               <a:t>НАЧАЛЬНИК ЦДНГ</a:t>
             </a:r>
@@ -7384,9 +7384,9 @@
                 <a:solidFill>
                   <a:srgbClr val="41008C"/>
                 </a:solidFill>
-                <a:latin typeface="Golos Text DemiBold" pitchFamily="34" charset="0"/>
-                <a:ea typeface="Golos Text DemiBold" pitchFamily="34" charset="-122"/>
-                <a:cs typeface="Golos Text DemiBold" pitchFamily="34" charset="-120"/>
+                <a:latin typeface="Arial" pitchFamily="34" charset="0"/>
+                <a:ea typeface="Arial" pitchFamily="34" charset="-122"/>
+                <a:cs typeface="Arial" pitchFamily="34" charset="-120"/>
               </a:rPr>
               <a:t>ЧТО ПЕРЕПРОЕКТИРОВАНО</a:t>
             </a:r>
@@ -7423,9 +7423,9 @@
                 <a:solidFill>
                   <a:srgbClr val="19003C"/>
                 </a:solidFill>
-                <a:latin typeface="Golos Text" pitchFamily="34" charset="0"/>
-                <a:ea typeface="Golos Text" pitchFamily="34" charset="-122"/>
-                <a:cs typeface="Golos Text" pitchFamily="34" charset="-120"/>
+                <a:latin typeface="Arial" pitchFamily="34" charset="0"/>
+                <a:ea typeface="Arial" pitchFamily="34" charset="-122"/>
+                <a:cs typeface="Arial" pitchFamily="34" charset="-120"/>
               </a:rPr>
               <a:t>Сравнение факта с прогнозом — триггер в начале, а не отчёт в конце. Гипотезы и проверка расчётом — один шаг по событию. Расчёт режима отделён от утверждения.</a:t>
             </a:r>
@@ -7482,9 +7482,9 @@
                 <a:solidFill>
                   <a:srgbClr val="41008C"/>
                 </a:solidFill>
-                <a:latin typeface="Golos Text DemiBold" pitchFamily="34" charset="0"/>
-                <a:ea typeface="Golos Text DemiBold" pitchFamily="34" charset="-122"/>
-                <a:cs typeface="Golos Text DemiBold" pitchFamily="34" charset="-120"/>
+                <a:latin typeface="Arial" pitchFamily="34" charset="0"/>
+                <a:ea typeface="Arial" pitchFamily="34" charset="-122"/>
+                <a:cs typeface="Arial" pitchFamily="34" charset="-120"/>
               </a:rPr>
               <a:t>КАК РАБОТАЕТ АГЕНТ</a:t>
             </a:r>
@@ -7521,9 +7521,9 @@
                 <a:solidFill>
                   <a:srgbClr val="19003C"/>
                 </a:solidFill>
-                <a:latin typeface="Golos Text" pitchFamily="34" charset="0"/>
-                <a:ea typeface="Golos Text" pitchFamily="34" charset="-122"/>
-                <a:cs typeface="Golos Text" pitchFamily="34" charset="-120"/>
+                <a:latin typeface="Arial" pitchFamily="34" charset="0"/>
+                <a:ea typeface="Arial" pitchFamily="34" charset="-122"/>
+                <a:cs typeface="Arial" pitchFamily="34" charset="-120"/>
               </a:rPr>
               <a:t>LLM предлагает гипотезы и наборы мероприятий, PROSPER и GAP проверяют их физикой и ограничениями сети, код выбирает лучший допустимый вариант.</a:t>
             </a:r>
@@ -7580,9 +7580,9 @@
                 <a:solidFill>
                   <a:srgbClr val="41008C"/>
                 </a:solidFill>
-                <a:latin typeface="Golos Text DemiBold" pitchFamily="34" charset="0"/>
-                <a:ea typeface="Golos Text DemiBold" pitchFamily="34" charset="-122"/>
-                <a:cs typeface="Golos Text DemiBold" pitchFamily="34" charset="-120"/>
+                <a:latin typeface="Arial" pitchFamily="34" charset="0"/>
+                <a:ea typeface="Arial" pitchFamily="34" charset="-122"/>
+                <a:cs typeface="Arial" pitchFamily="34" charset="-120"/>
               </a:rPr>
               <a:t>ОСТАВЛЕНО ЧЕЛОВЕКУ</a:t>
             </a:r>
@@ -7619,9 +7619,9 @@
                 <a:solidFill>
                   <a:srgbClr val="19003C"/>
                 </a:solidFill>
-                <a:latin typeface="Golos Text" pitchFamily="34" charset="0"/>
-                <a:ea typeface="Golos Text" pitchFamily="34" charset="-122"/>
-                <a:cs typeface="Golos Text" pitchFamily="34" charset="-120"/>
+                <a:latin typeface="Arial" pitchFamily="34" charset="0"/>
+                <a:ea typeface="Arial" pitchFamily="34" charset="-122"/>
+                <a:cs typeface="Arial" pitchFamily="34" charset="-120"/>
               </a:rPr>
               <a:t>Решение по режиму (необратимо, ответственность именная) и согласование с цехом (переговоры, нет программного входа).</a:t>
             </a:r>
@@ -7658,9 +7658,9 @@
                 <a:solidFill>
                   <a:srgbClr val="A7A6A6"/>
                 </a:solidFill>
-                <a:latin typeface="Golos Text" pitchFamily="34" charset="0"/>
-                <a:ea typeface="Golos Text" pitchFamily="34" charset="-122"/>
-                <a:cs typeface="Golos Text" pitchFamily="34" charset="-120"/>
+                <a:latin typeface="Arial" pitchFamily="34" charset="0"/>
+                <a:ea typeface="Arial" pitchFamily="34" charset="-122"/>
+                <a:cs typeface="Arial" pitchFamily="34" charset="-120"/>
               </a:rPr>
               <a:t>Агентных шагов 2 из 6. Данные не покидают сеть компании: LLM — GPT-OSS 120B на сервере LM Studio; облачные модели запрещены в конфигурации.</a:t>
             </a:r>
@@ -7773,9 +7773,9 @@
                 <a:solidFill>
                   <a:srgbClr val="A7A6A6"/>
                 </a:solidFill>
-                <a:latin typeface="Golos Text" pitchFamily="34" charset="0"/>
-                <a:ea typeface="Golos Text" pitchFamily="34" charset="-122"/>
-                <a:cs typeface="Golos Text" pitchFamily="34" charset="-120"/>
+                <a:latin typeface="Arial" pitchFamily="34" charset="0"/>
+                <a:ea typeface="Arial" pitchFamily="34" charset="-122"/>
+                <a:cs typeface="Arial" pitchFamily="34" charset="-120"/>
               </a:rPr>
               <a:t>5</a:t>
             </a:r>
@@ -7812,9 +7812,9 @@
                 <a:solidFill>
                   <a:srgbClr val="41008C"/>
                 </a:solidFill>
-                <a:latin typeface="Golos Text DemiBold" pitchFamily="34" charset="0"/>
-                <a:ea typeface="Golos Text DemiBold" pitchFamily="34" charset="-122"/>
-                <a:cs typeface="Golos Text DemiBold" pitchFamily="34" charset="-120"/>
+                <a:latin typeface="Arial" pitchFamily="34" charset="0"/>
+                <a:ea typeface="Arial" pitchFamily="34" charset="-122"/>
+                <a:cs typeface="Arial" pitchFamily="34" charset="-120"/>
               </a:rPr>
               <a:t>NS Digital</a:t>
             </a:r>
@@ -7826,9 +7826,9 @@
                 <a:solidFill>
                   <a:srgbClr val="19003C"/>
                 </a:solidFill>
-                <a:latin typeface="Golos Text DemiBold" pitchFamily="34" charset="0"/>
-                <a:ea typeface="Golos Text DemiBold" pitchFamily="34" charset="-122"/>
-                <a:cs typeface="Golos Text DemiBold" pitchFamily="34" charset="-120"/>
+                <a:latin typeface="Arial" pitchFamily="34" charset="0"/>
+                <a:ea typeface="Arial" pitchFamily="34" charset="-122"/>
+                <a:cs typeface="Arial" pitchFamily="34" charset="-120"/>
               </a:rPr>
               <a:t> / Метрики</a:t>
             </a:r>
@@ -7888,9 +7888,9 @@
                 <a:solidFill>
                   <a:srgbClr val="19003C"/>
                 </a:solidFill>
-                <a:latin typeface="Golos Text DemiBold" pitchFamily="34" charset="0"/>
-                <a:ea typeface="Golos Text DemiBold" pitchFamily="34" charset="-122"/>
-                <a:cs typeface="Golos Text DemiBold" pitchFamily="34" charset="-120"/>
+                <a:latin typeface="Arial" pitchFamily="34" charset="0"/>
+                <a:ea typeface="Arial" pitchFamily="34" charset="-122"/>
+                <a:cs typeface="Arial" pitchFamily="34" charset="-120"/>
               </a:rPr>
               <a:t>ЗНАЧЕНИЯ «ДО» — ИЗ АУДИТА И ЛИСТА AS-IS; «ПОСЛЕ» — ЗАМЕРЫ ПРОТОТИПА</a:t>
             </a:r>
@@ -7947,9 +7947,9 @@
                 <a:solidFill>
                   <a:srgbClr val="19003C"/>
                 </a:solidFill>
-                <a:latin typeface="Golos Text DemiBold" pitchFamily="34" charset="0"/>
-                <a:ea typeface="Golos Text DemiBold" pitchFamily="34" charset="-122"/>
-                <a:cs typeface="Golos Text DemiBold" pitchFamily="34" charset="-120"/>
+                <a:latin typeface="Arial" pitchFamily="34" charset="0"/>
+                <a:ea typeface="Arial" pitchFamily="34" charset="-122"/>
+                <a:cs typeface="Arial" pitchFamily="34" charset="-120"/>
               </a:rPr>
               <a:t>Обнаружение и расчёт</a:t>
             </a:r>
@@ -7986,9 +7986,9 @@
                 <a:solidFill>
                   <a:srgbClr val="A7A6A6"/>
                 </a:solidFill>
-                <a:latin typeface="Golos Text DemiBold" pitchFamily="34" charset="0"/>
-                <a:ea typeface="Golos Text DemiBold" pitchFamily="34" charset="-122"/>
-                <a:cs typeface="Golos Text DemiBold" pitchFamily="34" charset="-120"/>
+                <a:latin typeface="Arial" pitchFamily="34" charset="0"/>
+                <a:ea typeface="Arial" pitchFamily="34" charset="-122"/>
+                <a:cs typeface="Arial" pitchFamily="34" charset="-120"/>
               </a:rPr>
               <a:t>10 ч</a:t>
             </a:r>
@@ -8045,9 +8045,9 @@
                 <a:solidFill>
                   <a:srgbClr val="41008C"/>
                 </a:solidFill>
-                <a:latin typeface="Golos Text DemiBold" pitchFamily="34" charset="0"/>
-                <a:ea typeface="Golos Text DemiBold" pitchFamily="34" charset="-122"/>
-                <a:cs typeface="Golos Text DemiBold" pitchFamily="34" charset="-120"/>
+                <a:latin typeface="Arial" pitchFamily="34" charset="0"/>
+                <a:ea typeface="Arial" pitchFamily="34" charset="-122"/>
+                <a:cs typeface="Arial" pitchFamily="34" charset="-120"/>
               </a:rPr>
               <a:t>≤ 1.5 ч</a:t>
             </a:r>
@@ -8084,9 +8084,9 @@
                 <a:solidFill>
                   <a:srgbClr val="A7A6A6"/>
                 </a:solidFill>
-                <a:latin typeface="Golos Text" pitchFamily="34" charset="0"/>
-                <a:ea typeface="Golos Text" pitchFamily="34" charset="-122"/>
-                <a:cs typeface="Golos Text" pitchFamily="34" charset="-120"/>
+                <a:latin typeface="Arial" pitchFamily="34" charset="0"/>
+                <a:ea typeface="Arial" pitchFamily="34" charset="-122"/>
+                <a:cs typeface="Arial" pitchFamily="34" charset="-120"/>
               </a:rPr>
               <a:t>журнал тактов агента</a:t>
             </a:r>
@@ -8143,9 +8143,9 @@
                 <a:solidFill>
                   <a:srgbClr val="19003C"/>
                 </a:solidFill>
-                <a:latin typeface="Golos Text DemiBold" pitchFamily="34" charset="0"/>
-                <a:ea typeface="Golos Text DemiBold" pitchFamily="34" charset="-122"/>
-                <a:cs typeface="Golos Text DemiBold" pitchFamily="34" charset="-120"/>
+                <a:latin typeface="Arial" pitchFamily="34" charset="0"/>
+                <a:ea typeface="Arial" pitchFamily="34" charset="-122"/>
+                <a:cs typeface="Arial" pitchFamily="34" charset="-120"/>
               </a:rPr>
               <a:t>От обнаружения до действия</a:t>
             </a:r>
@@ -8182,9 +8182,9 @@
                 <a:solidFill>
                   <a:srgbClr val="A7A6A6"/>
                 </a:solidFill>
-                <a:latin typeface="Golos Text DemiBold" pitchFamily="34" charset="0"/>
-                <a:ea typeface="Golos Text DemiBold" pitchFamily="34" charset="-122"/>
-                <a:cs typeface="Golos Text DemiBold" pitchFamily="34" charset="-120"/>
+                <a:latin typeface="Arial" pitchFamily="34" charset="0"/>
+                <a:ea typeface="Arial" pitchFamily="34" charset="-122"/>
+                <a:cs typeface="Arial" pitchFamily="34" charset="-120"/>
               </a:rPr>
               <a:t>18 ч</a:t>
             </a:r>
@@ -8241,9 +8241,9 @@
                 <a:solidFill>
                   <a:srgbClr val="41008C"/>
                 </a:solidFill>
-                <a:latin typeface="Golos Text DemiBold" pitchFamily="34" charset="0"/>
-                <a:ea typeface="Golos Text DemiBold" pitchFamily="34" charset="-122"/>
-                <a:cs typeface="Golos Text DemiBold" pitchFamily="34" charset="-120"/>
+                <a:latin typeface="Arial" pitchFamily="34" charset="0"/>
+                <a:ea typeface="Arial" pitchFamily="34" charset="-122"/>
+                <a:cs typeface="Arial" pitchFamily="34" charset="-120"/>
               </a:rPr>
               <a:t>≈ 9.5 ч</a:t>
             </a:r>
@@ -8280,9 +8280,9 @@
                 <a:solidFill>
                   <a:srgbClr val="A7A6A6"/>
                 </a:solidFill>
-                <a:latin typeface="Golos Text" pitchFamily="34" charset="0"/>
-                <a:ea typeface="Golos Text" pitchFamily="34" charset="-122"/>
-                <a:cs typeface="Golos Text" pitchFamily="34" charset="-120"/>
+                <a:latin typeface="Arial" pitchFamily="34" charset="0"/>
+                <a:ea typeface="Arial" pitchFamily="34" charset="-122"/>
+                <a:cs typeface="Arial" pitchFamily="34" charset="-120"/>
               </a:rPr>
               <a:t>журнал + время решения</a:t>
             </a:r>
@@ -8339,9 +8339,9 @@
                 <a:solidFill>
                   <a:srgbClr val="19003C"/>
                 </a:solidFill>
-                <a:latin typeface="Golos Text DemiBold" pitchFamily="34" charset="0"/>
-                <a:ea typeface="Golos Text DemiBold" pitchFamily="34" charset="-122"/>
-                <a:cs typeface="Golos Text DemiBold" pitchFamily="34" charset="-120"/>
+                <a:latin typeface="Arial" pitchFamily="34" charset="0"/>
+                <a:ea typeface="Arial" pitchFamily="34" charset="-122"/>
+                <a:cs typeface="Arial" pitchFamily="34" charset="-120"/>
               </a:rPr>
               <a:t>Нескомпенсированная нефть на инцидент</a:t>
             </a:r>
@@ -8378,9 +8378,9 @@
                 <a:solidFill>
                   <a:srgbClr val="A7A6A6"/>
                 </a:solidFill>
-                <a:latin typeface="Golos Text DemiBold" pitchFamily="34" charset="0"/>
-                <a:ea typeface="Golos Text DemiBold" pitchFamily="34" charset="-122"/>
-                <a:cs typeface="Golos Text DemiBold" pitchFamily="34" charset="-120"/>
+                <a:latin typeface="Arial" pitchFamily="34" charset="0"/>
+                <a:ea typeface="Arial" pitchFamily="34" charset="-122"/>
+                <a:cs typeface="Arial" pitchFamily="34" charset="-120"/>
               </a:rPr>
               <a:t>10.7 т</a:t>
             </a:r>
@@ -8437,9 +8437,9 @@
                 <a:solidFill>
                   <a:srgbClr val="41008C"/>
                 </a:solidFill>
-                <a:latin typeface="Golos Text DemiBold" pitchFamily="34" charset="0"/>
-                <a:ea typeface="Golos Text DemiBold" pitchFamily="34" charset="-122"/>
-                <a:cs typeface="Golos Text DemiBold" pitchFamily="34" charset="-120"/>
+                <a:latin typeface="Arial" pitchFamily="34" charset="0"/>
+                <a:ea typeface="Arial" pitchFamily="34" charset="-122"/>
+                <a:cs typeface="Arial" pitchFamily="34" charset="-120"/>
               </a:rPr>
               <a:t>5.6 т</a:t>
             </a:r>
@@ -8476,9 +8476,9 @@
                 <a:solidFill>
                   <a:srgbClr val="A7A6A6"/>
                 </a:solidFill>
-                <a:latin typeface="Golos Text" pitchFamily="34" charset="0"/>
-                <a:ea typeface="Golos Text" pitchFamily="34" charset="-122"/>
-                <a:cs typeface="Golos Text" pitchFamily="34" charset="-120"/>
+                <a:latin typeface="Arial" pitchFamily="34" charset="0"/>
+                <a:ea typeface="Arial" pitchFamily="34" charset="-122"/>
+                <a:cs typeface="Arial" pitchFamily="34" charset="-120"/>
               </a:rPr>
               <a:t>потеря темпа × время / 24</a:t>
             </a:r>
@@ -8535,9 +8535,9 @@
                 <a:solidFill>
                   <a:srgbClr val="19003C"/>
                 </a:solidFill>
-                <a:latin typeface="Golos Text DemiBold" pitchFamily="34" charset="0"/>
-                <a:ea typeface="Golos Text DemiBold" pitchFamily="34" charset="-122"/>
-                <a:cs typeface="Golos Text DemiBold" pitchFamily="34" charset="-120"/>
+                <a:latin typeface="Arial" pitchFamily="34" charset="0"/>
+                <a:ea typeface="Arial" pitchFamily="34" charset="-122"/>
+                <a:cs typeface="Arial" pitchFamily="34" charset="-120"/>
               </a:rPr>
               <a:t>Время инженера-моделиста</a:t>
             </a:r>
@@ -8574,9 +8574,9 @@
                 <a:solidFill>
                   <a:srgbClr val="A7A6A6"/>
                 </a:solidFill>
-                <a:latin typeface="Golos Text DemiBold" pitchFamily="34" charset="0"/>
-                <a:ea typeface="Golos Text DemiBold" pitchFamily="34" charset="-122"/>
-                <a:cs typeface="Golos Text DemiBold" pitchFamily="34" charset="-120"/>
+                <a:latin typeface="Arial" pitchFamily="34" charset="0"/>
+                <a:ea typeface="Arial" pitchFamily="34" charset="-122"/>
+                <a:cs typeface="Arial" pitchFamily="34" charset="-120"/>
               </a:rPr>
               <a:t>552 мин/нед</a:t>
             </a:r>
@@ -8633,9 +8633,9 @@
                 <a:solidFill>
                   <a:srgbClr val="41008C"/>
                 </a:solidFill>
-                <a:latin typeface="Golos Text DemiBold" pitchFamily="34" charset="0"/>
-                <a:ea typeface="Golos Text DemiBold" pitchFamily="34" charset="-122"/>
-                <a:cs typeface="Golos Text DemiBold" pitchFamily="34" charset="-120"/>
+                <a:latin typeface="Arial" pitchFamily="34" charset="0"/>
+                <a:ea typeface="Arial" pitchFamily="34" charset="-122"/>
+                <a:cs typeface="Arial" pitchFamily="34" charset="-120"/>
               </a:rPr>
               <a:t>только эскалации</a:t>
             </a:r>
@@ -8672,9 +8672,9 @@
                 <a:solidFill>
                   <a:srgbClr val="A7A6A6"/>
                 </a:solidFill>
-                <a:latin typeface="Golos Text" pitchFamily="34" charset="0"/>
-                <a:ea typeface="Golos Text" pitchFamily="34" charset="-122"/>
-                <a:cs typeface="Golos Text" pitchFamily="34" charset="-120"/>
+                <a:latin typeface="Arial" pitchFamily="34" charset="0"/>
+                <a:ea typeface="Arial" pitchFamily="34" charset="-122"/>
+                <a:cs typeface="Arial" pitchFamily="34" charset="-120"/>
               </a:rPr>
               <a:t>очередь эскалаций</a:t>
             </a:r>
@@ -8733,9 +8733,9 @@
                 <a:solidFill>
                   <a:srgbClr val="FFFFFF"/>
                 </a:solidFill>
-                <a:latin typeface="Golos Text DemiBold" pitchFamily="34" charset="0"/>
-                <a:ea typeface="Golos Text DemiBold" pitchFamily="34" charset="-122"/>
-                <a:cs typeface="Golos Text DemiBold" pitchFamily="34" charset="-120"/>
+                <a:latin typeface="Arial" pitchFamily="34" charset="0"/>
+                <a:ea typeface="Arial" pitchFamily="34" charset="-122"/>
+                <a:cs typeface="Arial" pitchFamily="34" charset="-120"/>
               </a:rPr>
               <a:t>Проверено: eval-набор 15 из 15; серия пяти прогонов на PetEx — 5 из 5 успешных</a:t>
             </a:r>
@@ -8772,9 +8772,9 @@
                 <a:solidFill>
                   <a:srgbClr val="A7A6A6"/>
                 </a:solidFill>
-                <a:latin typeface="Golos Text" pitchFamily="34" charset="0"/>
-                <a:ea typeface="Golos Text" pitchFamily="34" charset="-122"/>
-                <a:cs typeface="Golos Text" pitchFamily="34" charset="-120"/>
+                <a:latin typeface="Arial" pitchFamily="34" charset="0"/>
+                <a:ea typeface="Arial" pitchFamily="34" charset="-122"/>
+                <a:cs typeface="Arial" pitchFamily="34" charset="-120"/>
               </a:rPr>
               <a:t>Серия пяти прогонов — учебные сутки, облачная модель прототипа. Локальная GPT-OSS 120B: пробные вызовы, серия — в shadow.</a:t>
             </a:r>
@@ -8887,9 +8887,9 @@
                 <a:solidFill>
                   <a:srgbClr val="A7A6A6"/>
                 </a:solidFill>
-                <a:latin typeface="Golos Text" pitchFamily="34" charset="0"/>
-                <a:ea typeface="Golos Text" pitchFamily="34" charset="-122"/>
-                <a:cs typeface="Golos Text" pitchFamily="34" charset="-120"/>
+                <a:latin typeface="Arial" pitchFamily="34" charset="0"/>
+                <a:ea typeface="Arial" pitchFamily="34" charset="-122"/>
+                <a:cs typeface="Arial" pitchFamily="34" charset="-120"/>
               </a:rPr>
               <a:t>6</a:t>
             </a:r>
@@ -8926,9 +8926,9 @@
                 <a:solidFill>
                   <a:srgbClr val="41008C"/>
                 </a:solidFill>
-                <a:latin typeface="Golos Text DemiBold" pitchFamily="34" charset="0"/>
-                <a:ea typeface="Golos Text DemiBold" pitchFamily="34" charset="-122"/>
-                <a:cs typeface="Golos Text DemiBold" pitchFamily="34" charset="-120"/>
+                <a:latin typeface="Arial" pitchFamily="34" charset="0"/>
+                <a:ea typeface="Arial" pitchFamily="34" charset="-122"/>
+                <a:cs typeface="Arial" pitchFamily="34" charset="-120"/>
               </a:rPr>
               <a:t>NS Digital</a:t>
             </a:r>
@@ -8940,9 +8940,9 @@
                 <a:solidFill>
                   <a:srgbClr val="19003C"/>
                 </a:solidFill>
-                <a:latin typeface="Golos Text DemiBold" pitchFamily="34" charset="0"/>
-                <a:ea typeface="Golos Text DemiBold" pitchFamily="34" charset="-122"/>
-                <a:cs typeface="Golos Text DemiBold" pitchFamily="34" charset="-120"/>
+                <a:latin typeface="Arial" pitchFamily="34" charset="0"/>
+                <a:ea typeface="Arial" pitchFamily="34" charset="-122"/>
+                <a:cs typeface="Arial" pitchFamily="34" charset="-120"/>
               </a:rPr>
               <a:t> / Запуск</a:t>
             </a:r>
@@ -9002,11 +9002,11 @@
                 <a:solidFill>
                   <a:srgbClr val="19003C"/>
                 </a:solidFill>
-                <a:latin typeface="Golos Text DemiBold" pitchFamily="34" charset="0"/>
-                <a:ea typeface="Golos Text DemiBold" pitchFamily="34" charset="-122"/>
-                <a:cs typeface="Golos Text DemiBold" pitchFamily="34" charset="-120"/>
-              </a:rPr>
-              <a:t>ПИЛОТ: ОДИН КУСТ BEL_PROD (16 СКВАЖИН), 6 НЕДЕЛЬ, БЕЗ ИСПОЛНЕНИЯ УСТАВОК</a:t>
+                <a:latin typeface="Arial" pitchFamily="34" charset="0"/>
+                <a:ea typeface="Arial" pitchFamily="34" charset="-122"/>
+                <a:cs typeface="Arial" pitchFamily="34" charset="-120"/>
+              </a:rPr>
+              <a:t>ПИЛОТ 01.12.2026–25.01.2027: ОДИН КУСТ BEL_PROD, ИНЖЕНЕР-МОДЕЛИСТ И ТЕХНОЛОГ</a:t>
             </a:r>
             <a:endParaRPr lang="en-US" sz="1700" dirty="0"/>
           </a:p>
@@ -9061,9 +9061,9 @@
                 <a:solidFill>
                   <a:srgbClr val="FFFFFF"/>
                 </a:solidFill>
-                <a:latin typeface="Golos Text DemiBold" pitchFamily="34" charset="0"/>
-                <a:ea typeface="Golos Text DemiBold" pitchFamily="34" charset="-122"/>
-                <a:cs typeface="Golos Text DemiBold" pitchFamily="34" charset="-120"/>
+                <a:latin typeface="Arial" pitchFamily="34" charset="0"/>
+                <a:ea typeface="Arial" pitchFamily="34" charset="-122"/>
+                <a:cs typeface="Arial" pitchFamily="34" charset="-120"/>
               </a:rPr>
               <a:t>SHADOW</a:t>
             </a:r>
@@ -9100,9 +9100,9 @@
                 <a:solidFill>
                   <a:srgbClr val="A7A6A6"/>
                 </a:solidFill>
-                <a:latin typeface="Golos Text DemiBold" pitchFamily="34" charset="0"/>
-                <a:ea typeface="Golos Text DemiBold" pitchFamily="34" charset="-122"/>
-                <a:cs typeface="Golos Text DemiBold" pitchFamily="34" charset="-120"/>
+                <a:latin typeface="Arial" pitchFamily="34" charset="0"/>
+                <a:ea typeface="Arial" pitchFamily="34" charset="-122"/>
+                <a:cs typeface="Arial" pitchFamily="34" charset="-120"/>
               </a:rPr>
               <a:t>2 НЕДЕЛИ</a:t>
             </a:r>
@@ -9139,9 +9139,9 @@
                 <a:solidFill>
                   <a:srgbClr val="19003C"/>
                 </a:solidFill>
-                <a:latin typeface="Golos Text" pitchFamily="34" charset="0"/>
-                <a:ea typeface="Golos Text" pitchFamily="34" charset="-122"/>
-                <a:cs typeface="Golos Text" pitchFamily="34" charset="-120"/>
+                <a:latin typeface="Arial" pitchFamily="34" charset="0"/>
+                <a:ea typeface="Arial" pitchFamily="34" charset="-122"/>
+                <a:cs typeface="Arial" pitchFamily="34" charset="-120"/>
               </a:rPr>
               <a:t>Агент считает по реальным данным, инженер работает как раньше, решения сравниваются</a:t>
             </a:r>
@@ -9201,9 +9201,9 @@
                 <a:solidFill>
                   <a:srgbClr val="41008C"/>
                 </a:solidFill>
-                <a:latin typeface="Golos Text" pitchFamily="34" charset="0"/>
-                <a:ea typeface="Golos Text" pitchFamily="34" charset="-122"/>
-                <a:cs typeface="Golos Text" pitchFamily="34" charset="-120"/>
+                <a:latin typeface="Arial" pitchFamily="34" charset="0"/>
+                <a:ea typeface="Arial" pitchFamily="34" charset="-122"/>
+                <a:cs typeface="Arial" pitchFamily="34" charset="-120"/>
               </a:rPr>
               <a:t>Переход дальше: </a:t>
             </a:r>
@@ -9215,11 +9215,11 @@
                 <a:solidFill>
                   <a:srgbClr val="19003C"/>
                 </a:solidFill>
-                <a:latin typeface="Golos Text" pitchFamily="34" charset="0"/>
-                <a:ea typeface="Golos Text" pitchFamily="34" charset="-122"/>
-                <a:cs typeface="Golos Text" pitchFamily="34" charset="-120"/>
-              </a:rPr>
-              <a:t>≥ 10 инцидентов; ≥ 80 % с готовым предложением; главная причина совпала в ≥ 70 %; 0 нарушений ограничений</a:t>
+                <a:latin typeface="Arial" pitchFamily="34" charset="0"/>
+                <a:ea typeface="Arial" pitchFamily="34" charset="-122"/>
+                <a:cs typeface="Arial" pitchFamily="34" charset="-120"/>
+              </a:rPr>
+              <a:t>≥ 10 инцидентов; 80 % — готовое предложение; причина совпала в 70 %; 0 нарушений ограничений</a:t>
             </a:r>
             <a:endParaRPr lang="en-US" sz="1100" dirty="0"/>
           </a:p>
@@ -9274,9 +9274,9 @@
                 <a:solidFill>
                   <a:srgbClr val="41008C"/>
                 </a:solidFill>
-                <a:latin typeface="Golos Text DemiBold" pitchFamily="34" charset="0"/>
-                <a:ea typeface="Golos Text DemiBold" pitchFamily="34" charset="-122"/>
-                <a:cs typeface="Golos Text DemiBold" pitchFamily="34" charset="-120"/>
+                <a:latin typeface="Arial" pitchFamily="34" charset="0"/>
+                <a:ea typeface="Arial" pitchFamily="34" charset="-122"/>
+                <a:cs typeface="Arial" pitchFamily="34" charset="-120"/>
               </a:rPr>
               <a:t>HITL</a:t>
             </a:r>
@@ -9313,9 +9313,9 @@
                 <a:solidFill>
                   <a:srgbClr val="A7A6A6"/>
                 </a:solidFill>
-                <a:latin typeface="Golos Text DemiBold" pitchFamily="34" charset="0"/>
-                <a:ea typeface="Golos Text DemiBold" pitchFamily="34" charset="-122"/>
-                <a:cs typeface="Golos Text DemiBold" pitchFamily="34" charset="-120"/>
+                <a:latin typeface="Arial" pitchFamily="34" charset="0"/>
+                <a:ea typeface="Arial" pitchFamily="34" charset="-122"/>
+                <a:cs typeface="Arial" pitchFamily="34" charset="-120"/>
               </a:rPr>
               <a:t>4 НЕДЕЛИ</a:t>
             </a:r>
@@ -9352,9 +9352,9 @@
                 <a:solidFill>
                   <a:srgbClr val="19003C"/>
                 </a:solidFill>
-                <a:latin typeface="Golos Text" pitchFamily="34" charset="0"/>
-                <a:ea typeface="Golos Text" pitchFamily="34" charset="-122"/>
-                <a:cs typeface="Golos Text" pitchFamily="34" charset="-120"/>
+                <a:latin typeface="Arial" pitchFamily="34" charset="0"/>
+                <a:ea typeface="Arial" pitchFamily="34" charset="-122"/>
+                <a:cs typeface="Arial" pitchFamily="34" charset="-120"/>
               </a:rPr>
               <a:t>Предложения идут технологу на утверждение, затем согласование с цехом</a:t>
             </a:r>
@@ -9414,9 +9414,9 @@
                 <a:solidFill>
                   <a:srgbClr val="41008C"/>
                 </a:solidFill>
-                <a:latin typeface="Golos Text" pitchFamily="34" charset="0"/>
-                <a:ea typeface="Golos Text" pitchFamily="34" charset="-122"/>
-                <a:cs typeface="Golos Text" pitchFamily="34" charset="-120"/>
+                <a:latin typeface="Arial" pitchFamily="34" charset="0"/>
+                <a:ea typeface="Arial" pitchFamily="34" charset="-122"/>
+                <a:cs typeface="Arial" pitchFamily="34" charset="-120"/>
               </a:rPr>
               <a:t>Переход дальше: </a:t>
             </a:r>
@@ -9428,9 +9428,9 @@
                 <a:solidFill>
                   <a:srgbClr val="19003C"/>
                 </a:solidFill>
-                <a:latin typeface="Golos Text" pitchFamily="34" charset="0"/>
-                <a:ea typeface="Golos Text" pitchFamily="34" charset="-122"/>
-                <a:cs typeface="Golos Text" pitchFamily="34" charset="-120"/>
+                <a:latin typeface="Arial" pitchFamily="34" charset="0"/>
+                <a:ea typeface="Arial" pitchFamily="34" charset="-122"/>
+                <a:cs typeface="Arial" pitchFamily="34" charset="-120"/>
               </a:rPr>
               <a:t>≥ 20 утверждённых; ≥ 70 % без переделки; факт в пределах прогноза ±5 %</a:t>
             </a:r>
@@ -9487,9 +9487,9 @@
                 <a:solidFill>
                   <a:srgbClr val="41008C"/>
                 </a:solidFill>
-                <a:latin typeface="Golos Text DemiBold" pitchFamily="34" charset="0"/>
-                <a:ea typeface="Golos Text DemiBold" pitchFamily="34" charset="-122"/>
-                <a:cs typeface="Golos Text DemiBold" pitchFamily="34" charset="-120"/>
+                <a:latin typeface="Arial" pitchFamily="34" charset="0"/>
+                <a:ea typeface="Arial" pitchFamily="34" charset="-122"/>
+                <a:cs typeface="Arial" pitchFamily="34" charset="-120"/>
               </a:rPr>
               <a:t>AUTONOMOUS</a:t>
             </a:r>
@@ -9526,9 +9526,9 @@
                 <a:solidFill>
                   <a:srgbClr val="A7A6A6"/>
                 </a:solidFill>
-                <a:latin typeface="Golos Text DemiBold" pitchFamily="34" charset="0"/>
-                <a:ea typeface="Golos Text DemiBold" pitchFamily="34" charset="-122"/>
-                <a:cs typeface="Golos Text DemiBold" pitchFamily="34" charset="-120"/>
+                <a:latin typeface="Arial" pitchFamily="34" charset="0"/>
+                <a:ea typeface="Arial" pitchFamily="34" charset="-122"/>
+                <a:cs typeface="Arial" pitchFamily="34" charset="-120"/>
               </a:rPr>
               <a:t>ОГРАНИЧЕННЫЙ</a:t>
             </a:r>
@@ -9565,9 +9565,9 @@
                 <a:solidFill>
                   <a:srgbClr val="19003C"/>
                 </a:solidFill>
-                <a:latin typeface="Golos Text" pitchFamily="34" charset="0"/>
-                <a:ea typeface="Golos Text" pitchFamily="34" charset="-122"/>
-                <a:cs typeface="Golos Text" pitchFamily="34" charset="-120"/>
+                <a:latin typeface="Arial" pitchFamily="34" charset="0"/>
+                <a:ea typeface="Arial" pitchFamily="34" charset="-122"/>
+                <a:cs typeface="Arial" pitchFamily="34" charset="-120"/>
               </a:rPr>
               <a:t>Агент ведёт контур до предложения и ставит задачу после утверждения; режим решает технолог</a:t>
             </a:r>
@@ -9627,9 +9627,9 @@
                 <a:solidFill>
                   <a:srgbClr val="19003C"/>
                 </a:solidFill>
-                <a:latin typeface="Golos Text" pitchFamily="34" charset="0"/>
-                <a:ea typeface="Golos Text" pitchFamily="34" charset="-122"/>
-                <a:cs typeface="Golos Text" pitchFamily="34" charset="-120"/>
+                <a:latin typeface="Arial" pitchFamily="34" charset="0"/>
+                <a:ea typeface="Arial" pitchFamily="34" charset="-122"/>
+                <a:cs typeface="Arial" pitchFamily="34" charset="-120"/>
               </a:rPr>
               <a:t>Откат в HITL: расхождение с прогнозом &gt; 10 % дважды за неделю</a:t>
             </a:r>
@@ -9688,9 +9688,9 @@
                 <a:solidFill>
                   <a:srgbClr val="FFFFFF"/>
                 </a:solidFill>
-                <a:latin typeface="Golos Text DemiBold" pitchFamily="34" charset="0"/>
-                <a:ea typeface="Golos Text DemiBold" pitchFamily="34" charset="-122"/>
-                <a:cs typeface="Golos Text DemiBold" pitchFamily="34" charset="-120"/>
+                <a:latin typeface="Arial" pitchFamily="34" charset="0"/>
+                <a:ea typeface="Arial" pitchFamily="34" charset="-122"/>
+                <a:cs typeface="Arial" pitchFamily="34" charset="-120"/>
               </a:rPr>
               <a:t>Немедленная остановка: данные за контуром, запись без утверждения, 2 рекомендации с нарушением ограничений</a:t>
             </a:r>
@@ -9727,9 +9727,9 @@
                 <a:solidFill>
                   <a:srgbClr val="A7A6A6"/>
                 </a:solidFill>
-                <a:latin typeface="Golos Text" pitchFamily="34" charset="0"/>
-                <a:ea typeface="Golos Text" pitchFamily="34" charset="-122"/>
-                <a:cs typeface="Golos Text" pitchFamily="34" charset="-120"/>
+                <a:latin typeface="Arial" pitchFamily="34" charset="0"/>
+                <a:ea typeface="Arial" pitchFamily="34" charset="-122"/>
+                <a:cs typeface="Arial" pitchFamily="34" charset="-120"/>
               </a:rPr>
               <a:t>Ответственный за починку — инженер-моделист, вторая линия — руководитель группы моделирования и оптимизации; риски и мониторинг — паспорт, Р7.</a:t>
             </a:r>
@@ -9842,9 +9842,9 @@
                 <a:solidFill>
                   <a:srgbClr val="A7A6A6"/>
                 </a:solidFill>
-                <a:latin typeface="Golos Text" pitchFamily="34" charset="0"/>
-                <a:ea typeface="Golos Text" pitchFamily="34" charset="-122"/>
-                <a:cs typeface="Golos Text" pitchFamily="34" charset="-120"/>
+                <a:latin typeface="Arial" pitchFamily="34" charset="0"/>
+                <a:ea typeface="Arial" pitchFamily="34" charset="-122"/>
+                <a:cs typeface="Arial" pitchFamily="34" charset="-120"/>
               </a:rPr>
               <a:t>7</a:t>
             </a:r>
@@ -9881,9 +9881,9 @@
                 <a:solidFill>
                   <a:srgbClr val="41008C"/>
                 </a:solidFill>
-                <a:latin typeface="Golos Text DemiBold" pitchFamily="34" charset="0"/>
-                <a:ea typeface="Golos Text DemiBold" pitchFamily="34" charset="-122"/>
-                <a:cs typeface="Golos Text DemiBold" pitchFamily="34" charset="-120"/>
+                <a:latin typeface="Arial" pitchFamily="34" charset="0"/>
+                <a:ea typeface="Arial" pitchFamily="34" charset="-122"/>
+                <a:cs typeface="Arial" pitchFamily="34" charset="-120"/>
               </a:rPr>
               <a:t>NS Digital</a:t>
             </a:r>
@@ -9895,9 +9895,9 @@
                 <a:solidFill>
                   <a:srgbClr val="19003C"/>
                 </a:solidFill>
-                <a:latin typeface="Golos Text DemiBold" pitchFamily="34" charset="0"/>
-                <a:ea typeface="Golos Text DemiBold" pitchFamily="34" charset="-122"/>
-                <a:cs typeface="Golos Text DemiBold" pitchFamily="34" charset="-120"/>
+                <a:latin typeface="Arial" pitchFamily="34" charset="0"/>
+                <a:ea typeface="Arial" pitchFamily="34" charset="-122"/>
+                <a:cs typeface="Arial" pitchFamily="34" charset="-120"/>
               </a:rPr>
               <a:t> / Стоимость</a:t>
             </a:r>
@@ -9957,9 +9957,9 @@
                 <a:solidFill>
                   <a:srgbClr val="19003C"/>
                 </a:solidFill>
-                <a:latin typeface="Golos Text DemiBold" pitchFamily="34" charset="0"/>
-                <a:ea typeface="Golos Text DemiBold" pitchFamily="34" charset="-122"/>
-                <a:cs typeface="Golos Text DemiBold" pitchFamily="34" charset="-120"/>
+                <a:latin typeface="Arial" pitchFamily="34" charset="0"/>
+                <a:ea typeface="Arial" pitchFamily="34" charset="-122"/>
+                <a:cs typeface="Arial" pitchFamily="34" charset="-120"/>
               </a:rPr>
               <a:t>УСПЕШНЫЙ РЕЗУЛЬТАТ ПОЧТИ БЕСПЛАТЕН — ОЖИДАНИЕ СТОИТ ≈ 100 ТЫС. РУБ НА ИНЦИДЕНТ</a:t>
             </a:r>
@@ -9996,9 +9996,9 @@
                 <a:solidFill>
                   <a:srgbClr val="00DD00"/>
                 </a:solidFill>
-                <a:latin typeface="Golos Text DemiBold" pitchFamily="34" charset="0"/>
-                <a:ea typeface="Golos Text DemiBold" pitchFamily="34" charset="-122"/>
-                <a:cs typeface="Golos Text DemiBold" pitchFamily="34" charset="-120"/>
+                <a:latin typeface="Arial" pitchFamily="34" charset="0"/>
+                <a:ea typeface="Arial" pitchFamily="34" charset="-122"/>
+                <a:cs typeface="Arial" pitchFamily="34" charset="-120"/>
               </a:rPr>
               <a:t>≈ 100 тыс. руб</a:t>
             </a:r>
@@ -10035,9 +10035,9 @@
                 <a:solidFill>
                   <a:srgbClr val="19003C"/>
                 </a:solidFill>
-                <a:latin typeface="Golos Text" pitchFamily="34" charset="0"/>
-                <a:ea typeface="Golos Text" pitchFamily="34" charset="-122"/>
-                <a:cs typeface="Golos Text" pitchFamily="34" charset="-120"/>
+                <a:latin typeface="Arial" pitchFamily="34" charset="0"/>
+                <a:ea typeface="Arial" pitchFamily="34" charset="-122"/>
+                <a:cs typeface="Arial" pitchFamily="34" charset="-120"/>
               </a:rPr>
               <a:t>сохранённой нефти на инцидент: ≈ 5 т, время до действия 18 ч → ≈ 9.5 ч</a:t>
             </a:r>
@@ -10074,11 +10074,11 @@
                 <a:solidFill>
                   <a:srgbClr val="41008C"/>
                 </a:solidFill>
-                <a:latin typeface="Golos Text DemiBold" pitchFamily="34" charset="0"/>
-                <a:ea typeface="Golos Text DemiBold" pitchFamily="34" charset="-122"/>
-                <a:cs typeface="Golos Text DemiBold" pitchFamily="34" charset="-120"/>
-              </a:rPr>
-              <a:t>0 руб</a:t>
+                <a:latin typeface="Arial" pitchFamily="34" charset="0"/>
+                <a:ea typeface="Arial" pitchFamily="34" charset="-122"/>
+                <a:cs typeface="Arial" pitchFamily="34" charset="-120"/>
+              </a:rPr>
+              <a:t>0 внешних</a:t>
             </a:r>
             <a:endParaRPr lang="en-US" sz="3200" dirty="0"/>
           </a:p>
@@ -10113,11 +10113,11 @@
                 <a:solidFill>
                   <a:srgbClr val="19003C"/>
                 </a:solidFill>
-                <a:latin typeface="Golos Text" pitchFamily="34" charset="0"/>
-                <a:ea typeface="Golos Text" pitchFamily="34" charset="-122"/>
-                <a:cs typeface="Golos Text" pitchFamily="34" charset="-120"/>
-              </a:rPr>
-              <a:t>LLM в контуре: сервер LM Studio и лицензия PetEx уже есть</a:t>
+                <a:latin typeface="Arial" pitchFamily="34" charset="0"/>
+                <a:ea typeface="Arial" pitchFamily="34" charset="-122"/>
+                <a:cs typeface="Arial" pitchFamily="34" charset="-120"/>
+              </a:rPr>
+              <a:t>LLM на своём сервере: ~5.6 ч работы в месяц (&lt; 1 % загрузки); API стоил бы $0.17–2.35 в месяц, но данные не покидают контур</a:t>
             </a:r>
             <a:endParaRPr lang="en-US" sz="1200" dirty="0"/>
           </a:p>
@@ -10152,9 +10152,9 @@
                 <a:solidFill>
                   <a:srgbClr val="41008C"/>
                 </a:solidFill>
-                <a:latin typeface="Golos Text DemiBold" pitchFamily="34" charset="0"/>
-                <a:ea typeface="Golos Text DemiBold" pitchFamily="34" charset="-122"/>
-                <a:cs typeface="Golos Text DemiBold" pitchFamily="34" charset="-120"/>
+                <a:latin typeface="Arial" pitchFamily="34" charset="0"/>
+                <a:ea typeface="Arial" pitchFamily="34" charset="-122"/>
+                <a:cs typeface="Arial" pitchFamily="34" charset="-120"/>
               </a:rPr>
               <a:t>≈ 20 руб</a:t>
             </a:r>
@@ -10191,9 +10191,9 @@
                 <a:solidFill>
                   <a:srgbClr val="19003C"/>
                 </a:solidFill>
-                <a:latin typeface="Golos Text" pitchFamily="34" charset="0"/>
-                <a:ea typeface="Golos Text" pitchFamily="34" charset="-122"/>
-                <a:cs typeface="Golos Text" pitchFamily="34" charset="-120"/>
+                <a:latin typeface="Arial" pitchFamily="34" charset="0"/>
+                <a:ea typeface="Arial" pitchFamily="34" charset="-122"/>
+                <a:cs typeface="Arial" pitchFamily="34" charset="-120"/>
               </a:rPr>
               <a:t>стоимость успешного результата облачной LLM для сравнения ($0.23, 5 из 5) — облако запрещено</a:t>
             </a:r>
@@ -10250,9 +10250,9 @@
                 <a:solidFill>
                   <a:srgbClr val="41008C"/>
                 </a:solidFill>
-                <a:latin typeface="Golos Text DemiBold" pitchFamily="34" charset="0"/>
-                <a:ea typeface="Golos Text DemiBold" pitchFamily="34" charset="-122"/>
-                <a:cs typeface="Golos Text DemiBold" pitchFamily="34" charset="-120"/>
+                <a:latin typeface="Arial" pitchFamily="34" charset="0"/>
+                <a:ea typeface="Arial" pitchFamily="34" charset="-122"/>
+                <a:cs typeface="Arial" pitchFamily="34" charset="-120"/>
               </a:rPr>
               <a:t>ЗАТРАТЫ НА ИНЦИДЕНТ</a:t>
             </a:r>
@@ -10292,9 +10292,9 @@
                 <a:solidFill>
                   <a:srgbClr val="19003C"/>
                 </a:solidFill>
-                <a:latin typeface="Golos Text" pitchFamily="34" charset="0"/>
-                <a:ea typeface="Golos Text" pitchFamily="34" charset="-122"/>
-                <a:cs typeface="Golos Text" pitchFamily="34" charset="-120"/>
+                <a:latin typeface="Arial" pitchFamily="34" charset="0"/>
+                <a:ea typeface="Arial" pitchFamily="34" charset="-122"/>
+                <a:cs typeface="Arial" pitchFamily="34" charset="-120"/>
               </a:rPr>
               <a:t>2–3 вызова LLM, 11–19 мин</a:t>
             </a:r>
@@ -10312,9 +10312,9 @@
                 <a:solidFill>
                   <a:srgbClr val="19003C"/>
                 </a:solidFill>
-                <a:latin typeface="Golos Text" pitchFamily="34" charset="0"/>
-                <a:ea typeface="Golos Text" pitchFamily="34" charset="-122"/>
-                <a:cs typeface="Golos Text" pitchFamily="34" charset="-120"/>
+                <a:latin typeface="Arial" pitchFamily="34" charset="0"/>
+                <a:ea typeface="Arial" pitchFamily="34" charset="-122"/>
+                <a:cs typeface="Arial" pitchFamily="34" charset="-120"/>
               </a:rPr>
               <a:t>4 запуска GAP, до 2 PROSPER, 5–8 мин</a:t>
             </a:r>
@@ -10332,9 +10332,9 @@
                 <a:solidFill>
                   <a:srgbClr val="19003C"/>
                 </a:solidFill>
-                <a:latin typeface="Golos Text" pitchFamily="34" charset="0"/>
-                <a:ea typeface="Golos Text" pitchFamily="34" charset="-122"/>
-                <a:cs typeface="Golos Text" pitchFamily="34" charset="-120"/>
+                <a:latin typeface="Arial" pitchFamily="34" charset="0"/>
+                <a:ea typeface="Arial" pitchFamily="34" charset="-122"/>
+                <a:cs typeface="Arial" pitchFamily="34" charset="-120"/>
               </a:rPr>
               <a:t>такт с инцидентом 17–25 мин</a:t>
             </a:r>
@@ -10352,9 +10352,9 @@
                 <a:solidFill>
                   <a:srgbClr val="19003C"/>
                 </a:solidFill>
-                <a:latin typeface="Golos Text" pitchFamily="34" charset="0"/>
-                <a:ea typeface="Golos Text" pitchFamily="34" charset="-122"/>
-                <a:cs typeface="Golos Text" pitchFamily="34" charset="-120"/>
+                <a:latin typeface="Arial" pitchFamily="34" charset="0"/>
+                <a:ea typeface="Arial" pitchFamily="34" charset="-122"/>
+                <a:cs typeface="Arial" pitchFamily="34" charset="-120"/>
               </a:rPr>
               <a:t> </a:t>
             </a:r>
@@ -10372,9 +10372,9 @@
                 <a:solidFill>
                   <a:srgbClr val="41008C"/>
                 </a:solidFill>
-                <a:latin typeface="Golos Text" pitchFamily="34" charset="0"/>
-                <a:ea typeface="Golos Text" pitchFamily="34" charset="-122"/>
-                <a:cs typeface="Golos Text" pitchFamily="34" charset="-120"/>
+                <a:latin typeface="Arial" pitchFamily="34" charset="0"/>
+                <a:ea typeface="Arial" pitchFamily="34" charset="-122"/>
+                <a:cs typeface="Arial" pitchFamily="34" charset="-120"/>
               </a:rPr>
               <a:t>ПОТОЛКИ</a:t>
             </a:r>
@@ -10392,9 +10392,9 @@
                 <a:solidFill>
                   <a:srgbClr val="19003C"/>
                 </a:solidFill>
-                <a:latin typeface="Golos Text" pitchFamily="34" charset="0"/>
-                <a:ea typeface="Golos Text" pitchFamily="34" charset="-122"/>
-                <a:cs typeface="Golos Text" pitchFamily="34" charset="-120"/>
+                <a:latin typeface="Arial" pitchFamily="34" charset="0"/>
+                <a:ea typeface="Arial" pitchFamily="34" charset="-122"/>
+                <a:cs typeface="Arial" pitchFamily="34" charset="-120"/>
               </a:rPr>
               <a:t>20 вызовов LLM и 30 GAP в сутки, $1.5 в сутки, такт 45 мин; после потолка агент стоит до разбора</a:t>
             </a:r>
@@ -10453,9 +10453,9 @@
                 <a:solidFill>
                   <a:srgbClr val="FFFFFF"/>
                 </a:solidFill>
-                <a:latin typeface="Golos Text DemiBold" pitchFamily="34" charset="0"/>
-                <a:ea typeface="Golos Text DemiBold" pitchFamily="34" charset="-122"/>
-                <a:cs typeface="Golos Text DemiBold" pitchFamily="34" charset="-120"/>
+                <a:latin typeface="Arial" pitchFamily="34" charset="0"/>
+                <a:ea typeface="Arial" pitchFamily="34" charset="-122"/>
+                <a:cs typeface="Arial" pitchFamily="34" charset="-120"/>
               </a:rPr>
               <a:t>Почему не оставить как есть: каждый инцидент — ≈ 5 т нефти (≈ 100 тыс. руб), потерянных за 8.5 лишних часов</a:t>
             </a:r>
@@ -10492,9 +10492,9 @@
                 <a:solidFill>
                   <a:srgbClr val="A7A6A6"/>
                 </a:solidFill>
-                <a:latin typeface="Golos Text" pitchFamily="34" charset="0"/>
-                <a:ea typeface="Golos Text" pitchFamily="34" charset="-122"/>
-                <a:cs typeface="Golos Text" pitchFamily="34" charset="-120"/>
+                <a:latin typeface="Arial" pitchFamily="34" charset="0"/>
+                <a:ea typeface="Arial" pitchFamily="34" charset="-122"/>
+                <a:cs typeface="Arial" pitchFamily="34" charset="-120"/>
               </a:rPr>
               <a:t>Расчёт на учебном кейсе (потеря 14.2 т/сут, 20 000 руб/т); 8 ч после расчёта оставлены без изменений — осторожная оценка.</a:t>
             </a:r>

</xml_diff>

<commit_message>
Ownership sheet: 1 incident/day per bush, pilot and 100-bush TCO, break-even per incident; deck slide 7, defense and defense frames for the operations director
Co-Authored-By: Claude Opus 5.5 <noreply@anthropic.com>
</commit_message>
<xml_diff>
--- a/course/deck/agent_deck.pptx
+++ b/course/deck/agent_deck.pptx
@@ -9961,7 +9961,7 @@
                 <a:ea typeface="Arial" pitchFamily="34" charset="-122"/>
                 <a:cs typeface="Arial" pitchFamily="34" charset="-120"/>
               </a:rPr>
-              <a:t>УСПЕШНЫЙ РЕЗУЛЬТАТ ПОЧТИ БЕСПЛАТЕН — ОЖИДАНИЕ СТОИТ ≈ 100 ТЫС. РУБ НА ИНЦИДЕНТ</a:t>
+              <a:t>ОКУПАЕТСЯ ПРИ ≥ 0.15 Т НЕФТИ НА ИНЦИДЕНТ, В КЕЙСЕ — ≈ 5 Т</a:t>
             </a:r>
             <a:endParaRPr lang="en-US" sz="1700" dirty="0"/>
           </a:p>
@@ -10078,7 +10078,7 @@
                 <a:ea typeface="Arial" pitchFamily="34" charset="-122"/>
                 <a:cs typeface="Arial" pitchFamily="34" charset="-120"/>
               </a:rPr>
-              <a:t>0 внешних</a:t>
+              <a:t>≈ 0.9 млн ₽</a:t>
             </a:r>
             <a:endParaRPr lang="en-US" sz="3200" dirty="0"/>
           </a:p>
@@ -10117,7 +10117,7 @@
                 <a:ea typeface="Arial" pitchFamily="34" charset="-122"/>
                 <a:cs typeface="Arial" pitchFamily="34" charset="-120"/>
               </a:rPr>
-              <a:t>LLM на своём сервере: ~5.6 ч работы в месяц (&lt; 1 % загрузки); API стоил бы $0.17–2.35 в месяц, но данные не покидают контур</a:t>
+              <a:t>пилот на 1 куст: внедрение 0.8 млн ₽ + время людей; для Заказчика бесплатно, железо — нынешний сервер</a:t>
             </a:r>
             <a:endParaRPr lang="en-US" sz="1200" dirty="0"/>
           </a:p>
@@ -10156,7 +10156,7 @@
                 <a:ea typeface="Arial" pitchFamily="34" charset="-122"/>
                 <a:cs typeface="Arial" pitchFamily="34" charset="-120"/>
               </a:rPr>
-              <a:t>≈ 20 руб</a:t>
+              <a:t>112 млн ₽</a:t>
             </a:r>
             <a:endParaRPr lang="en-US" sz="3200" dirty="0"/>
           </a:p>
@@ -10195,7 +10195,7 @@
                 <a:ea typeface="Arial" pitchFamily="34" charset="-122"/>
                 <a:cs typeface="Arial" pitchFamily="34" charset="-120"/>
               </a:rPr>
-              <a:t>стоимость успешного результата облачной LLM для сравнения ($0.23, 5 из 5) — облако запрещено</a:t>
+              <a:t>100 кустов в первый год: железо 2 млн, внедрение 80 млн, сопровождение 30 млн; дальше ≈ 30.4 млн ₽ в год</a:t>
             </a:r>
             <a:endParaRPr lang="en-US" sz="1200" dirty="0"/>
           </a:p>
@@ -10254,7 +10254,7 @@
                 <a:ea typeface="Arial" pitchFamily="34" charset="-122"/>
                 <a:cs typeface="Arial" pitchFamily="34" charset="-120"/>
               </a:rPr>
-              <a:t>ЗАТРАТЫ НА ИНЦИДЕНТ</a:t>
+              <a:t>ПОРОГ ОКУПАЕМОСТИ</a:t>
             </a:r>
             <a:endParaRPr lang="en-US" sz="1200" dirty="0"/>
           </a:p>
@@ -10296,7 +10296,7 @@
                 <a:ea typeface="Arial" pitchFamily="34" charset="-122"/>
                 <a:cs typeface="Arial" pitchFamily="34" charset="-120"/>
               </a:rPr>
-              <a:t>2–3 вызова LLM, 11–19 мин</a:t>
+              <a:t>1 инцидент в сутки на куст: 36 500 в год на 100 кустов</a:t>
             </a:r>
             <a:endParaRPr lang="en-US" sz="1200" dirty="0"/>
           </a:p>
@@ -10316,7 +10316,7 @@
                 <a:ea typeface="Arial" pitchFamily="34" charset="-122"/>
                 <a:cs typeface="Arial" pitchFamily="34" charset="-120"/>
               </a:rPr>
-              <a:t>4 запуска GAP, до 2 PROSPER, 5–8 мин</a:t>
+              <a:t>первый год: 112 млн ₽ ÷ 36 500 ≈ 0.15 т на инцидент</a:t>
             </a:r>
             <a:endParaRPr lang="en-US" sz="1200" dirty="0"/>
           </a:p>
@@ -10336,7 +10336,7 @@
                 <a:ea typeface="Arial" pitchFamily="34" charset="-122"/>
                 <a:cs typeface="Arial" pitchFamily="34" charset="-120"/>
               </a:rPr>
-              <a:t>такт с инцидентом 17–25 мин</a:t>
+              <a:t>следующие годы: ≈ 0.04 т на инцидент</a:t>
             </a:r>
             <a:endParaRPr lang="en-US" sz="1200" dirty="0"/>
           </a:p>
@@ -10496,7 +10496,7 @@
                 <a:ea typeface="Arial" pitchFamily="34" charset="-122"/>
                 <a:cs typeface="Arial" pitchFamily="34" charset="-120"/>
               </a:rPr>
-              <a:t>Расчёт на учебном кейсе (потеря 14.2 т/сут, 20 000 руб/т); 8 ч после расчёта оставлены без изменений — осторожная оценка.</a:t>
+              <a:t>Учебный кейс: потеря 14.2 т/сут, 20 000 руб/т, 8 ч после расчёта без изменений. Сопровождение (~5 ч в месяц на куст) — оценка; эффект в год даст пилот.</a:t>
             </a:r>
             <a:endParaRPr lang="en-US" sz="900" dirty="0"/>
           </a:p>

</xml_diff>

<commit_message>
TCO recalculated for 1 incident per 100 wells (15 wells per bush): 97 mln RUB first year, break-even 0.89 t per incident
Co-Authored-By: Claude Opus 5.5 <noreply@anthropic.com>
</commit_message>
<xml_diff>
--- a/course/deck/agent_deck.pptx
+++ b/course/deck/agent_deck.pptx
@@ -9961,7 +9961,7 @@
                 <a:ea typeface="Arial" pitchFamily="34" charset="-122"/>
                 <a:cs typeface="Arial" pitchFamily="34" charset="-120"/>
               </a:rPr>
-              <a:t>ОКУПАЕТСЯ ПРИ ≥ 0.15 Т НЕФТИ НА ИНЦИДЕНТ, В КЕЙСЕ — ≈ 5 Т</a:t>
+              <a:t>ОКУПАЕТСЯ ПРИ ≥ 0.89 Т НЕФТИ НА ИНЦИДЕНТ, В КЕЙСЕ — ≈ 5 Т</a:t>
             </a:r>
             <a:endParaRPr lang="en-US" sz="1700" dirty="0"/>
           </a:p>
@@ -10078,7 +10078,7 @@
                 <a:ea typeface="Arial" pitchFamily="34" charset="-122"/>
                 <a:cs typeface="Arial" pitchFamily="34" charset="-120"/>
               </a:rPr>
-              <a:t>≈ 0.9 млн ₽</a:t>
+              <a:t>≈ 0.83 млн ₽</a:t>
             </a:r>
             <a:endParaRPr lang="en-US" sz="3200" dirty="0"/>
           </a:p>
@@ -10156,7 +10156,7 @@
                 <a:ea typeface="Arial" pitchFamily="34" charset="-122"/>
                 <a:cs typeface="Arial" pitchFamily="34" charset="-120"/>
               </a:rPr>
-              <a:t>112 млн ₽</a:t>
+              <a:t>97 млн ₽</a:t>
             </a:r>
             <a:endParaRPr lang="en-US" sz="3200" dirty="0"/>
           </a:p>
@@ -10195,7 +10195,7 @@
                 <a:ea typeface="Arial" pitchFamily="34" charset="-122"/>
                 <a:cs typeface="Arial" pitchFamily="34" charset="-120"/>
               </a:rPr>
-              <a:t>100 кустов в первый год: железо 2 млн, внедрение 80 млн, сопровождение 30 млн; дальше ≈ 30.4 млн ₽ в год</a:t>
+              <a:t>100 кустов в первый год: железо 2 млн, внедрение 80 млн, сопровождение 15 млн; дальше ≈ 15.4 млн ₽ в год</a:t>
             </a:r>
             <a:endParaRPr lang="en-US" sz="1200" dirty="0"/>
           </a:p>
@@ -10296,7 +10296,7 @@
                 <a:ea typeface="Arial" pitchFamily="34" charset="-122"/>
                 <a:cs typeface="Arial" pitchFamily="34" charset="-120"/>
               </a:rPr>
-              <a:t>1 инцидент в сутки на куст: 36 500 в год на 100 кустов</a:t>
+              <a:t>1 инцидент в сутки на 100 скважин: 5 475 в год на 1 500 скважин</a:t>
             </a:r>
             <a:endParaRPr lang="en-US" sz="1200" dirty="0"/>
           </a:p>
@@ -10316,7 +10316,7 @@
                 <a:ea typeface="Arial" pitchFamily="34" charset="-122"/>
                 <a:cs typeface="Arial" pitchFamily="34" charset="-120"/>
               </a:rPr>
-              <a:t>первый год: 112 млн ₽ ÷ 36 500 ≈ 0.15 т на инцидент</a:t>
+              <a:t>первый год: 97 млн ₽ ÷ 5 475 ≈ 0.89 т на инцидент</a:t>
             </a:r>
             <a:endParaRPr lang="en-US" sz="1200" dirty="0"/>
           </a:p>
@@ -10336,7 +10336,7 @@
                 <a:ea typeface="Arial" pitchFamily="34" charset="-122"/>
                 <a:cs typeface="Arial" pitchFamily="34" charset="-120"/>
               </a:rPr>
-              <a:t>следующие годы: ≈ 0.04 т на инцидент</a:t>
+              <a:t>следующие годы: ≈ 0.14 т на инцидент</a:t>
             </a:r>
             <a:endParaRPr lang="en-US" sz="1200" dirty="0"/>
           </a:p>
@@ -10496,7 +10496,7 @@
                 <a:ea typeface="Arial" pitchFamily="34" charset="-122"/>
                 <a:cs typeface="Arial" pitchFamily="34" charset="-120"/>
               </a:rPr>
-              <a:t>Учебный кейс: потеря 14.2 т/сут, 20 000 руб/т, 8 ч после расчёта без изменений. Сопровождение (~5 ч в месяц на куст) — оценка; эффект в год даст пилот.</a:t>
+              <a:t>Учебный кейс: потеря 14.2 т/сут, 20 000 руб/т, 8 ч после расчёта без изменений. Сопровождение (~2.5 ч в месяц на куст) — оценка; эффект в год даст пилот.</a:t>
             </a:r>
             <a:endParaRPr lang="en-US" sz="900" dirty="0"/>
           </a:p>

</xml_diff>

<commit_message>
Implementation estimated by level (system, field, bush): 9 mln RUB for 3 fields / 100 bushes, first year 26 mln, break-even 0.24 t per incident
Co-Authored-By: Claude Opus 5.5 <noreply@anthropic.com>
</commit_message>
<xml_diff>
--- a/course/deck/agent_deck.pptx
+++ b/course/deck/agent_deck.pptx
@@ -9961,7 +9961,7 @@
                 <a:ea typeface="Arial" pitchFamily="34" charset="-122"/>
                 <a:cs typeface="Arial" pitchFamily="34" charset="-120"/>
               </a:rPr>
-              <a:t>ОКУПАЕТСЯ ПРИ ≥ 0.89 Т НЕФТИ НА ИНЦИДЕНТ, В КЕЙСЕ — ≈ 5 Т</a:t>
+              <a:t>ОКУПАЕТСЯ ПРИ ≥ 0.24 Т НЕФТИ НА ИНЦИДЕНТ, В КЕЙСЕ — ≈ 5 Т</a:t>
             </a:r>
             <a:endParaRPr lang="en-US" sz="1700" dirty="0"/>
           </a:p>
@@ -10078,7 +10078,7 @@
                 <a:ea typeface="Arial" pitchFamily="34" charset="-122"/>
                 <a:cs typeface="Arial" pitchFamily="34" charset="-120"/>
               </a:rPr>
-              <a:t>≈ 0.83 млн ₽</a:t>
+              <a:t>≈ 1.5 млн ₽</a:t>
             </a:r>
             <a:endParaRPr lang="en-US" sz="3200" dirty="0"/>
           </a:p>
@@ -10117,7 +10117,7 @@
                 <a:ea typeface="Arial" pitchFamily="34" charset="-122"/>
                 <a:cs typeface="Arial" pitchFamily="34" charset="-120"/>
               </a:rPr>
-              <a:t>пилот на 1 куст: внедрение 0.8 млн ₽ + время людей; для Заказчика бесплатно, железо — нынешний сервер</a:t>
+              <a:t>пилот на 1 куст: внедрение системы, месторождения и куста + время людей; для Заказчика бесплатно, железо — нынешний сервер</a:t>
             </a:r>
             <a:endParaRPr lang="en-US" sz="1200" dirty="0"/>
           </a:p>
@@ -10156,7 +10156,7 @@
                 <a:ea typeface="Arial" pitchFamily="34" charset="-122"/>
                 <a:cs typeface="Arial" pitchFamily="34" charset="-120"/>
               </a:rPr>
-              <a:t>97 млн ₽</a:t>
+              <a:t>26 млн ₽</a:t>
             </a:r>
             <a:endParaRPr lang="en-US" sz="3200" dirty="0"/>
           </a:p>
@@ -10195,7 +10195,7 @@
                 <a:ea typeface="Arial" pitchFamily="34" charset="-122"/>
                 <a:cs typeface="Arial" pitchFamily="34" charset="-120"/>
               </a:rPr>
-              <a:t>100 кустов в первый год: железо 2 млн, внедрение 80 млн, сопровождение 15 млн; дальше ≈ 15.4 млн ₽ в год</a:t>
+              <a:t>100 кустов, 3 месторождения, первый год: железо 2 млн, внедрение 9 млн, сопровождение 15 млн; дальше ≈ 15.4 млн ₽ в год</a:t>
             </a:r>
             <a:endParaRPr lang="en-US" sz="1200" dirty="0"/>
           </a:p>
@@ -10316,7 +10316,7 @@
                 <a:ea typeface="Arial" pitchFamily="34" charset="-122"/>
                 <a:cs typeface="Arial" pitchFamily="34" charset="-120"/>
               </a:rPr>
-              <a:t>первый год: 97 млн ₽ ÷ 5 475 ≈ 0.89 т на инцидент</a:t>
+              <a:t>первый год: 26 млн ₽ ÷ 5 475 ≈ 0.24 т на инцидент</a:t>
             </a:r>
             <a:endParaRPr lang="en-US" sz="1200" dirty="0"/>
           </a:p>
@@ -10496,7 +10496,7 @@
                 <a:ea typeface="Arial" pitchFamily="34" charset="-122"/>
                 <a:cs typeface="Arial" pitchFamily="34" charset="-120"/>
               </a:rPr>
-              <a:t>Учебный кейс: потеря 14.2 т/сут, 20 000 руб/т, 8 ч после расчёта без изменений. Сопровождение (~2.5 ч в месяц на куст) — оценка; эффект в год даст пилот.</a:t>
+              <a:t>Учебный кейс: потеря 14.2 т/сут, 20 000 руб/т, 8 ч после расчёта без изменений. Внедрение и сопровождение — оценка; эффект в год даст пилот.</a:t>
             </a:r>
             <a:endParaRPr lang="en-US" sz="900" dirty="0"/>
           </a:p>

</xml_diff>

<commit_message>
Pilot option A: 7 bushes of one field (~105 wells, ~1 incident/day) so rollout criteria are reachable; pilot cost 1.92 mln RUB
Co-Authored-By: Claude Opus 5.5 <noreply@anthropic.com>
</commit_message>
<xml_diff>
--- a/course/deck/agent_deck.pptx
+++ b/course/deck/agent_deck.pptx
@@ -9006,7 +9006,7 @@
                 <a:ea typeface="Arial" pitchFamily="34" charset="-122"/>
                 <a:cs typeface="Arial" pitchFamily="34" charset="-120"/>
               </a:rPr>
-              <a:t>ПИЛОТ 01.12.2026–25.01.2027: ОДИН КУСТ BEL_PROD, ИНЖЕНЕР-МОДЕЛИСТ И ТЕХНОЛОГ</a:t>
+              <a:t>ПИЛОТ 01.12.2026–25.01.2027: 7 КУСТОВ, ~105 СКВАЖИН, ~1 ИНЦИДЕНТ В СУТКИ</a:t>
             </a:r>
             <a:endParaRPr lang="en-US" sz="1700" dirty="0"/>
           </a:p>
@@ -10078,7 +10078,7 @@
                 <a:ea typeface="Arial" pitchFamily="34" charset="-122"/>
                 <a:cs typeface="Arial" pitchFamily="34" charset="-120"/>
               </a:rPr>
-              <a:t>≈ 1.5 млн ₽</a:t>
+              <a:t>≈ 1.9 млн ₽</a:t>
             </a:r>
             <a:endParaRPr lang="en-US" sz="3200" dirty="0"/>
           </a:p>
@@ -10117,7 +10117,7 @@
                 <a:ea typeface="Arial" pitchFamily="34" charset="-122"/>
                 <a:cs typeface="Arial" pitchFamily="34" charset="-120"/>
               </a:rPr>
-              <a:t>пилот на 1 куст: внедрение системы, месторождения и куста + время людей; для Заказчика бесплатно, железо — нынешний сервер</a:t>
+              <a:t>пилот на 7 кустах: внедрение системы, месторождения и кустов + время людей; для Заказчика бесплатно, железо — нынешний сервер</a:t>
             </a:r>
             <a:endParaRPr lang="en-US" sz="1200" dirty="0"/>
           </a:p>

</xml_diff>

<commit_message>
Slide 7 banner and defense answer use the typical well (10.9 t, 218k RUB per incident); deck rebuilt
Co-Authored-By: Claude Opus 5.5 <noreply@anthropic.com>
</commit_message>
<xml_diff>
--- a/course/deck/agent_deck.pptx
+++ b/course/deck/agent_deck.pptx
@@ -9961,7 +9961,7 @@
                 <a:ea typeface="Arial" pitchFamily="34" charset="-122"/>
                 <a:cs typeface="Arial" pitchFamily="34" charset="-120"/>
               </a:rPr>
-              <a:t>ОКУПАЕТСЯ ПРИ ≥ 0.24 Т НЕФТИ НА ИНЦИДЕНТ, В КЕЙСЕ — ≈ 5 Т</a:t>
+              <a:t>ОКУПАЕТСЯ ПРИ ≥ 11.5 Т НЕФТИ НА КУСТ В ГОД</a:t>
             </a:r>
             <a:endParaRPr lang="en-US" sz="1700" dirty="0"/>
           </a:p>
@@ -10039,7 +10039,7 @@
                 <a:ea typeface="Arial" pitchFamily="34" charset="-122"/>
                 <a:cs typeface="Arial" pitchFamily="34" charset="-120"/>
               </a:rPr>
-              <a:t>сохранённой нефти на инцидент: ≈ 5 т, время до действия 18 ч → ≈ 9.5 ч</a:t>
+              <a:t>сохранённой нефти на инцидент учебного кейса: ≈ 5 т, время до действия 18 ч → ≈ 9.5 ч</a:t>
             </a:r>
             <a:endParaRPr lang="en-US" sz="1200" dirty="0"/>
           </a:p>
@@ -10156,7 +10156,7 @@
                 <a:ea typeface="Arial" pitchFamily="34" charset="-122"/>
                 <a:cs typeface="Arial" pitchFamily="34" charset="-120"/>
               </a:rPr>
-              <a:t>26 млн ₽</a:t>
+              <a:t>23 млн ₽</a:t>
             </a:r>
             <a:endParaRPr lang="en-US" sz="3200" dirty="0"/>
           </a:p>
@@ -10195,7 +10195,7 @@
                 <a:ea typeface="Arial" pitchFamily="34" charset="-122"/>
                 <a:cs typeface="Arial" pitchFamily="34" charset="-120"/>
               </a:rPr>
-              <a:t>100 кустов, 3 месторождения, первый год: железо 2 млн, внедрение 9 млн, сопровождение 15 млн; дальше ≈ 15.4 млн ₽ в год</a:t>
+              <a:t>100 кустов, 3 месторождения, первый год: железо 2 млн, внедрение 9 млн, сопровождение 12 млн; дальше ≈ 12.4 млн ₽ в год</a:t>
             </a:r>
             <a:endParaRPr lang="en-US" sz="1200" dirty="0"/>
           </a:p>
@@ -10296,7 +10296,7 @@
                 <a:ea typeface="Arial" pitchFamily="34" charset="-122"/>
                 <a:cs typeface="Arial" pitchFamily="34" charset="-120"/>
               </a:rPr>
-              <a:t>1 инцидент в сутки на 100 скважин: 5 475 в год на 1 500 скважин</a:t>
+              <a:t>первый год: 23 млн ₽ ÷ 100 кустов ≈ 11.5 т нефти на куст</a:t>
             </a:r>
             <a:endParaRPr lang="en-US" sz="1200" dirty="0"/>
           </a:p>
@@ -10316,7 +10316,7 @@
                 <a:ea typeface="Arial" pitchFamily="34" charset="-122"/>
                 <a:cs typeface="Arial" pitchFamily="34" charset="-120"/>
               </a:rPr>
-              <a:t>первый год: 26 млн ₽ ÷ 5 475 ≈ 0.24 т на инцидент</a:t>
+              <a:t>следующие годы: ≈ 6.2 т на куст</a:t>
             </a:r>
             <a:endParaRPr lang="en-US" sz="1200" dirty="0"/>
           </a:p>
@@ -10336,7 +10336,7 @@
                 <a:ea typeface="Arial" pitchFamily="34" charset="-122"/>
                 <a:cs typeface="Arial" pitchFamily="34" charset="-120"/>
               </a:rPr>
-              <a:t>следующие годы: ≈ 0.14 т на инцидент</a:t>
+              <a:t>один инцидент типичной скважины (60 м³/сут, 30 % воды) — ≈ 10.9 т</a:t>
             </a:r>
             <a:endParaRPr lang="en-US" sz="1200" dirty="0"/>
           </a:p>
@@ -10457,7 +10457,7 @@
                 <a:ea typeface="Arial" pitchFamily="34" charset="-122"/>
                 <a:cs typeface="Arial" pitchFamily="34" charset="-120"/>
               </a:rPr>
-              <a:t>Почему не оставить как есть: каждый инцидент — ≈ 5 т нефти (≈ 100 тыс. руб), потерянных за 8.5 лишних часов</a:t>
+              <a:t>Почему не оставить как есть: инцидент на типичной скважине — ≈ 10.9 т нефти (≈ 218 тыс. руб), потерянных за 8.5 лишних часов</a:t>
             </a:r>
             <a:endParaRPr lang="en-US" sz="1400" dirty="0"/>
           </a:p>
@@ -10496,7 +10496,7 @@
                 <a:ea typeface="Arial" pitchFamily="34" charset="-122"/>
                 <a:cs typeface="Arial" pitchFamily="34" charset="-120"/>
               </a:rPr>
-              <a:t>Учебный кейс: потеря 14.2 т/сут, 20 000 руб/т, 8 ч после расчёта без изменений. Внедрение и сопровождение — оценка; эффект в год даст пилот.</a:t>
+              <a:t>Учебный кейс: потеря 14.2 т/сут, 20 000 руб/т, 8 ч после расчёта без изменений. Типичная скважина 60 м³/сут, 30 % воды — оценка. Внедрение и сопровождение — оценка; эффект в год даст пилот.</a:t>
             </a:r>
             <a:endParaRPr lang="en-US" sz="900" dirty="0"/>
           </a:p>

</xml_diff>

<commit_message>
Five-run series on the working configuration (GPT-OSS 120B, own server): 3 of 5, ~3.8 RUB per successful result; failures are tick timeout with two incidents and a server outage
Co-Authored-By: Claude Opus 5.5 <noreply@anthropic.com>
</commit_message>
<xml_diff>
--- a/course/deck/agent_deck.pptx
+++ b/course/deck/agent_deck.pptx
@@ -8737,7 +8737,7 @@
                 <a:ea typeface="Arial" pitchFamily="34" charset="-122"/>
                 <a:cs typeface="Arial" pitchFamily="34" charset="-120"/>
               </a:rPr>
-              <a:t>Проверено: eval-набор 15 из 15; серия пяти прогонов на PetEx — 5 из 5 успешных</a:t>
+              <a:t>Проверено: eval-набор 15 из 15; серия пяти прогонов на своём сервере — 3 из 5, облачная — 5 из 5</a:t>
             </a:r>
             <a:endParaRPr lang="en-US" sz="1400" dirty="0"/>
           </a:p>
@@ -8776,7 +8776,7 @@
                 <a:ea typeface="Arial" pitchFamily="34" charset="-122"/>
                 <a:cs typeface="Arial" pitchFamily="34" charset="-120"/>
               </a:rPr>
-              <a:t>Серия пяти прогонов — учебные сутки, облачная модель прототипа. Локальная GPT-OSS 120B: пробные вызовы, серия — в shadow.</a:t>
+              <a:t>Учебные сутки, настоящий PetEx. Своя модель: неудачи — тайм-аут на такте с двумя инцидентами и сбой сервера, не неверный ответ; ≈ 3.8 ₽ за успешный результат.</a:t>
             </a:r>
             <a:endParaRPr lang="en-US" sz="900" dirty="0"/>
           </a:p>

</xml_diff>